<commit_message>
Regenerate the deck with the corrected flow-rule findings
Carries the source changes from the previous commit into the .pptx, which was
open in PowerPoint at the time and could not be overwritten.

Verified: 49 slides, no layout problems, and a content scan confirms the six
corrected facts are present (264 connector transitions, 0 conditional, UTF-16BE,
bodies extracted, 87-132 days, rework-condition workshops) and the five stale
claims are gone (cannot be decoded, Dev Studio, 93-141, bodies not decodable,
proprietary binary). The revised effort column also sums exactly to the stated
87-132 total.

Co-authored-by: Copilot App <223556219+Copilot@users.noreply.github.com>
</commit_message>
<xml_diff>
--- a/lending-due-diligence-app/docs/Pega-to-PowerPlatform-Migration-PoC.pptx
+++ b/lending-due-diligence-app/docs/Pega-to-PowerPlatform-Migration-PoC.pptx
@@ -830,7 +830,7 @@
           <a:lstStyle/>
           <a:p>
             <a:r>
-              <a:t>This slide pre-empts the obvious challenge - 'could better tooling have extracted more?' The answer is no, and the file sizes are cited as evidence.</a:t>
+              <a:t>This slide originally claimed the rule bodies could not be decoded outside a Pega instance, repeating the extraction tool's own documentation. That was wrong, and testing it changed the recommendation: there are no guards to recover, so the engine's re-visit cap is permanent design rather than a stopgap.</a:t>
             </a:r>
           </a:p>
         </p:txBody>
@@ -4653,7 +4653,7 @@
                 </a:solidFill>
                 <a:latin typeface="Segoe UI"/>
               </a:rPr>
-              <a:t>Rule logic is not portable</a:t>
+              <a:t>Rule bodies are recoverable - but only if you know the encoding</a:t>
             </a:r>
           </a:p>
           <a:p>
@@ -4672,7 +4672,7 @@
                 </a:solidFill>
                 <a:latin typeface="Segoe UI"/>
               </a:rPr>
-              <a:t>•  Rule bodies ship as proprietary binaries. The export contains rules.jar at 22.9 MB, holding instances_*.bin members up to 26.6 MB, which cannot be decoded outside a Pega instance.</a:t>
+              <a:t>•  Rule bodies ship inside rules.jar as a Java-serialised stream. An ASCII scan finds nothing, so the format is widely assumed opaque. The payload strings are UTF-16BE; decoding them makes every rule body readable.</a:t>
             </a:r>
           </a:p>
           <a:p>
@@ -4691,7 +4691,7 @@
                 </a:solidFill>
                 <a:latin typeface="Segoe UI"/>
               </a:rPr>
-              <a:t>Conditional routing is invisible</a:t>
+              <a:t>Conditional routing genuinely does not exist</a:t>
             </a:r>
           </a:p>
           <a:p>
@@ -4710,7 +4710,7 @@
                 </a:solidFill>
                 <a:latin typeface="Segoe UI"/>
               </a:rPr>
-              <a:t>•  The when conditions that guard stage transitions live inside compiled flow rules. They are absent from every exportable artefact - export, application document and the DX API alike.</a:t>
+              <a:t>•  Having extracted the flow bodies, all 264 connector transitions are unconditional - 225 Always, 32 Action, 7 Else. Not one is when-guarded.</a:t>
             </a:r>
           </a:p>
           <a:p>
@@ -4729,7 +4729,7 @@
                 </a:solidFill>
                 <a:latin typeface="Segoe UI"/>
               </a:rPr>
-              <a:t>Behaviour is locked to the engine</a:t>
+              <a:t>Behaviour is still locked to the engine</a:t>
             </a:r>
           </a:p>
           <a:p>
@@ -4916,7 +4916,7 @@
                 </a:solidFill>
                 <a:latin typeface="Segoe UI"/>
               </a:rPr>
-              <a:t>These are platform constraints, not gaps in the migration tooling. Any migration approach faces them identically.</a:t>
+              <a:t>The routing finding is a defect in the source application, not a migration gap - those flows really would loop.</a:t>
             </a:r>
           </a:p>
         </p:txBody>
@@ -9939,13 +9939,13 @@
                     <a:lstStyle/>
                     <a:p>
                       <a:r>
-                        <a:rPr sz="1150" b="0">
-                          <a:solidFill>
-                            <a:srgbClr val="3C3C3C"/>
-                          </a:solidFill>
-                          <a:latin typeface="Segoe UI"/>
-                        </a:rPr>
-                        <a:t>Inventory only</a:t>
+                        <a:rPr sz="1150" b="1">
+                          <a:solidFill>
+                            <a:srgbClr val="1A1A1A"/>
+                          </a:solidFill>
+                          <a:latin typeface="Segoe UI"/>
+                        </a:rPr>
+                        <a:t>Bodies extracted</a:t>
                       </a:r>
                     </a:p>
                   </a:txBody>
@@ -9967,7 +9967,7 @@
                           </a:solidFill>
                           <a:latin typeface="Segoe UI"/>
                         </a:rPr>
-                        <a:t>Bodies not decodable</a:t>
+                        <a:t>0 conditional transitions</a:t>
                       </a:r>
                     </a:p>
                   </a:txBody>
@@ -13494,7 +13494,7 @@
                           </a:solidFill>
                           <a:latin typeface="Segoe UI"/>
                         </a:rPr>
-                        <a:t>Flow when conditions can be recovered from Dev Studio or business workshops</a:t>
+                        <a:t>Rework conditions can be agreed with the business</a:t>
                       </a:r>
                     </a:p>
                   </a:txBody>
@@ -13516,7 +13516,7 @@
                           </a:solidFill>
                           <a:latin typeface="Segoe UI"/>
                         </a:rPr>
-                        <a:t>Guards remain inferred - the main open risk</a:t>
+                        <a:t>Extraction proved none exist in Pega to recover</a:t>
                       </a:r>
                     </a:p>
                   </a:txBody>
@@ -18720,7 +18720,7 @@
                           </a:solidFill>
                           <a:latin typeface="Segoe UI"/>
                         </a:rPr>
-                        <a:t>Transform rules compile into the proprietary binary</a:t>
+                        <a:t>Transform bodies are engine-executed with no exported representation</a:t>
                       </a:r>
                     </a:p>
                   </a:txBody>
@@ -18856,7 +18856,7 @@
                           </a:solidFill>
                           <a:latin typeface="Segoe UI"/>
                         </a:rPr>
-                        <a:t>when conditions live inside compiled flow rules</a:t>
+                        <a:t>Extraction shows Pega has no conditional transitions at all</a:t>
                       </a:r>
                     </a:p>
                   </a:txBody>
@@ -20164,13 +20164,13 @@
                     <a:lstStyle/>
                     <a:p>
                       <a:r>
-                        <a:rPr sz="1150" b="0">
-                          <a:solidFill>
-                            <a:srgbClr val="3C3C3C"/>
-                          </a:solidFill>
-                          <a:latin typeface="Segoe UI"/>
-                        </a:rPr>
-                        <a:t>Improve with Dev Studio extraction</a:t>
+                        <a:rPr sz="1150" b="1">
+                          <a:solidFill>
+                            <a:srgbClr val="1A1A1A"/>
+                          </a:solidFill>
+                          <a:latin typeface="Segoe UI"/>
+                        </a:rPr>
+                        <a:t>Flow-rule extractor built and reusable</a:t>
                       </a:r>
                     </a:p>
                   </a:txBody>
@@ -24368,7 +24368,7 @@
                           </a:solidFill>
                           <a:latin typeface="Segoe UI"/>
                         </a:rPr>
-                        <a:t>Dev Studio extraction of 35 flow rules, or business workshops</a:t>
+                        <a:t>Extraction done - now a business decision on rework conditions</a:t>
                       </a:r>
                     </a:p>
                   </a:txBody>
@@ -25555,7 +25555,7 @@
                           </a:solidFill>
                           <a:latin typeface="Segoe UI"/>
                         </a:rPr>
-                        <a:t>Guard and flow logic recovery</a:t>
+                        <a:t>Rework-condition workshops</a:t>
                       </a:r>
                     </a:p>
                   </a:txBody>
@@ -25577,7 +25577,7 @@
                           </a:solidFill>
                           <a:latin typeface="Segoe UI"/>
                         </a:rPr>
-                        <a:t>35 flow rules, workshops</a:t>
+                        <a:t>Business decision, not extraction</a:t>
                       </a:r>
                     </a:p>
                   </a:txBody>
@@ -25599,7 +25599,7 @@
                           </a:solidFill>
                           <a:latin typeface="Segoe UI"/>
                         </a:rPr>
-                        <a:t>10 - 15</a:t>
+                        <a:t>4 - 6</a:t>
                       </a:r>
                     </a:p>
                   </a:txBody>
@@ -26279,7 +26279,7 @@
                           </a:solidFill>
                           <a:latin typeface="Segoe UI"/>
                         </a:rPr>
-                        <a:t>93 - 141</a:t>
+                        <a:t>87 - 132</a:t>
                       </a:r>
                     </a:p>
                   </a:txBody>
@@ -27430,7 +27430,7 @@
                           </a:solidFill>
                           <a:latin typeface="Segoe UI"/>
                         </a:rPr>
-                        <a:t>Book Dev Studio access and SME time before Phase 1 starts</a:t>
+                        <a:t>Book SME time before Phase 1 starts</a:t>
                       </a:r>
                     </a:p>
                   </a:txBody>
@@ -27980,7 +27980,7 @@
                           </a:solidFill>
                           <a:latin typeface="Segoe UI"/>
                         </a:rPr>
-                        <a:t>Pega Dev Studio access</a:t>
+                        <a:t>Business SME workshops</a:t>
                       </a:r>
                     </a:p>
                   </a:txBody>
@@ -28002,7 +28002,7 @@
                           </a:solidFill>
                           <a:latin typeface="Segoe UI"/>
                         </a:rPr>
-                        <a:t>Extracting the 35 flow rule bodies</a:t>
+                        <a:t>Agreeing the rework conditions</a:t>
                       </a:r>
                     </a:p>
                   </a:txBody>
@@ -28024,7 +28024,7 @@
                           </a:solidFill>
                           <a:latin typeface="Segoe UI"/>
                         </a:rPr>
-                        <a:t>Before Phase 1</a:t>
+                        <a:t>Phase 1 weeks 1 to 2</a:t>
                       </a:r>
                     </a:p>
                   </a:txBody>
@@ -28046,7 +28046,7 @@
                           </a:solidFill>
                           <a:latin typeface="Segoe UI"/>
                         </a:rPr>
-                        <a:t>Pega platform team</a:t>
+                        <a:t>Business</a:t>
                       </a:r>
                     </a:p>
                   </a:txBody>
@@ -29325,7 +29325,7 @@
                 </a:solidFill>
                 <a:latin typeface="Segoe UI"/>
               </a:rPr>
-              <a:t>•  Secure Pega Dev Studio access and business SME time before Phase 1 starts. These are the two hard dependencies, and both sit outside the delivery team.</a:t>
+              <a:t>•  Secure business SME time before Phase 1 starts. Flow-rule extraction is solved; what remains needs business input, not platform access.</a:t>
             </a:r>
           </a:p>
         </p:txBody>
@@ -36448,7 +36448,7 @@
                 </a:solidFill>
                 <a:latin typeface="Segoe UI"/>
               </a:rPr>
-              <a:t>•  Replace with the real when conditions from Dev Studio. Because guards are Dataverse rows, this is a data edit with no code change or redeploy.</a:t>
+              <a:t>•  Extraction proved Pega has no conditional transitions, so these encode a business decision rather than a recovered rule. Confirm with SMEs; because guards are Dataverse rows it is a data edit, no redeploy.</a:t>
             </a:r>
           </a:p>
         </p:txBody>

</xml_diff>

<commit_message>
Apply CIBC branding to the deck and app header
Repalette the migration deck to CIBC's actual brand colours, harvested
from the live site's stylesheets rather than eyeballed: red #C41F3E,
primary blue #007BA4, deep blue #005377, light blue #A0D3E8 and pale
blue #D3EDEE. Divider slides, the cover footer band and the closing
slide now reference the named constants instead of inline hex.

Replace the hand-rolled "CIBC" text and CSS diamond in AppHeader with
the real logo. The logo is bundled through Vite rather than hotlinked
from cibc.com - the remote SVG does not load inside the deployed Power
App and rendered as a broken image. Also promote the clickable brand
from a div to a button so it is reachable by keyboard.

Deck rebuilt (54 slides) and check-deck passes; app build is clean.

Co-authored-by: Copilot App <223556219+Copilot@users.noreply.github.com>
</commit_message>
<xml_diff>
--- a/lending-due-diligence-app/docs/Pega-to-PowerPlatform-Migration-PoC.pptx
+++ b/lending-due-diligence-app/docs/Pega-to-PowerPlatform-Migration-PoC.pptx
@@ -4390,7 +4390,7 @@
             <a:avLst/>
           </a:prstGeom>
           <a:solidFill>
-            <a:srgbClr val="C8102E"/>
+            <a:srgbClr val="C41F3E"/>
           </a:solidFill>
           <a:ln>
             <a:noFill/>
@@ -4434,7 +4434,7 @@
             <a:avLst/>
           </a:prstGeom>
           <a:solidFill>
-            <a:srgbClr val="006D77"/>
+            <a:srgbClr val="005377"/>
           </a:solidFill>
           <a:ln>
             <a:noFill/>
@@ -4496,7 +4496,7 @@
             <a:r>
               <a:rPr sz="1300" b="1" i="0">
                 <a:solidFill>
-                  <a:srgbClr val="006D77"/>
+                  <a:srgbClr val="007BA4"/>
                 </a:solidFill>
                 <a:latin typeface="Segoe UI"/>
               </a:rPr>
@@ -4557,7 +4557,7 @@
             <a:r>
               <a:rPr sz="4400" b="1" i="0">
                 <a:solidFill>
-                  <a:srgbClr val="C8102E"/>
+                  <a:srgbClr val="C41F3E"/>
                 </a:solidFill>
                 <a:latin typeface="Segoe UI"/>
               </a:rPr>
@@ -4581,7 +4581,7 @@
             <a:avLst/>
           </a:prstGeom>
           <a:solidFill>
-            <a:srgbClr val="006D77"/>
+            <a:srgbClr val="007BA4"/>
           </a:solidFill>
           <a:ln>
             <a:noFill/>
@@ -4788,7 +4788,7 @@
             <a:avLst/>
           </a:prstGeom>
           <a:solidFill>
-            <a:srgbClr val="C8102E"/>
+            <a:srgbClr val="C41F3E"/>
           </a:solidFill>
           <a:ln>
             <a:noFill/>
@@ -4850,7 +4850,7 @@
             <a:r>
               <a:rPr sz="1050" b="1" i="0">
                 <a:solidFill>
-                  <a:srgbClr val="006D77"/>
+                  <a:srgbClr val="007BA4"/>
                 </a:solidFill>
                 <a:latin typeface="Segoe UI"/>
               </a:rPr>
@@ -4944,7 +4944,7 @@
                   </a:txBody>
                   <a:tcPr anchor="ctr" marL="91440">
                     <a:solidFill>
-                      <a:srgbClr val="006D77"/>
+                      <a:srgbClr val="007BA4"/>
                     </a:solidFill>
                   </a:tcPr>
                 </a:tc>
@@ -4966,7 +4966,7 @@
                   </a:txBody>
                   <a:tcPr anchor="ctr" marL="91440">
                     <a:solidFill>
-                      <a:srgbClr val="006D77"/>
+                      <a:srgbClr val="007BA4"/>
                     </a:solidFill>
                   </a:tcPr>
                 </a:tc>
@@ -4988,7 +4988,7 @@
                   </a:txBody>
                   <a:tcPr anchor="ctr" marL="91440">
                     <a:solidFill>
-                      <a:srgbClr val="006D77"/>
+                      <a:srgbClr val="007BA4"/>
                     </a:solidFill>
                   </a:tcPr>
                 </a:tc>
@@ -5010,7 +5010,7 @@
                   </a:txBody>
                   <a:tcPr anchor="ctr" marL="91440">
                     <a:solidFill>
-                      <a:srgbClr val="006D77"/>
+                      <a:srgbClr val="007BA4"/>
                     </a:solidFill>
                   </a:tcPr>
                 </a:tc>
@@ -5754,7 +5754,7 @@
             <a:avLst/>
           </a:prstGeom>
           <a:solidFill>
-            <a:srgbClr val="C8102E"/>
+            <a:srgbClr val="C41F3E"/>
           </a:solidFill>
           <a:ln>
             <a:noFill/>
@@ -5816,7 +5816,7 @@
             <a:r>
               <a:rPr sz="1050" b="1" i="0">
                 <a:solidFill>
-                  <a:srgbClr val="006D77"/>
+                  <a:srgbClr val="007BA4"/>
                 </a:solidFill>
                 <a:latin typeface="Segoe UI"/>
               </a:rPr>
@@ -6247,7 +6247,7 @@
             <a:avLst/>
           </a:prstGeom>
           <a:solidFill>
-            <a:srgbClr val="006D77"/>
+            <a:srgbClr val="005377"/>
           </a:solidFill>
           <a:ln>
             <a:noFill/>
@@ -6291,7 +6291,7 @@
             <a:avLst/>
           </a:prstGeom>
           <a:solidFill>
-            <a:srgbClr val="C8102E"/>
+            <a:srgbClr val="C41F3E"/>
           </a:solidFill>
           <a:ln>
             <a:noFill/>
@@ -6353,7 +6353,7 @@
             <a:r>
               <a:rPr sz="6400" b="1" i="0">
                 <a:solidFill>
-                  <a:srgbClr val="7FC4CB"/>
+                  <a:srgbClr val="A0D3E8"/>
                 </a:solidFill>
                 <a:latin typeface="Segoe UI"/>
               </a:rPr>
@@ -6437,7 +6437,7 @@
             <a:r>
               <a:rPr sz="1450" b="0" i="0">
                 <a:solidFill>
-                  <a:srgbClr val="D6ECEE"/>
+                  <a:srgbClr val="D3EDEE"/>
                 </a:solidFill>
                 <a:latin typeface="Segoe UI"/>
               </a:rPr>
@@ -6521,7 +6521,7 @@
             <a:avLst/>
           </a:prstGeom>
           <a:solidFill>
-            <a:srgbClr val="C8102E"/>
+            <a:srgbClr val="C41F3E"/>
           </a:solidFill>
           <a:ln>
             <a:noFill/>
@@ -6583,7 +6583,7 @@
             <a:r>
               <a:rPr sz="1050" b="1" i="0">
                 <a:solidFill>
-                  <a:srgbClr val="006D77"/>
+                  <a:srgbClr val="007BA4"/>
                 </a:solidFill>
                 <a:latin typeface="Segoe UI"/>
               </a:rPr>
@@ -6737,7 +6737,7 @@
                   </a:txBody>
                   <a:tcPr anchor="ctr" marL="91440">
                     <a:solidFill>
-                      <a:srgbClr val="006D77"/>
+                      <a:srgbClr val="007BA4"/>
                     </a:solidFill>
                   </a:tcPr>
                 </a:tc>
@@ -6759,7 +6759,7 @@
                   </a:txBody>
                   <a:tcPr anchor="ctr" marL="91440">
                     <a:solidFill>
-                      <a:srgbClr val="006D77"/>
+                      <a:srgbClr val="007BA4"/>
                     </a:solidFill>
                   </a:tcPr>
                 </a:tc>
@@ -6781,7 +6781,7 @@
                   </a:txBody>
                   <a:tcPr anchor="ctr" marL="91440">
                     <a:solidFill>
-                      <a:srgbClr val="006D77"/>
+                      <a:srgbClr val="007BA4"/>
                     </a:solidFill>
                   </a:tcPr>
                 </a:tc>
@@ -7257,7 +7257,7 @@
             <a:avLst/>
           </a:prstGeom>
           <a:solidFill>
-            <a:srgbClr val="006D77"/>
+            <a:srgbClr val="007BA4"/>
           </a:solidFill>
           <a:ln>
             <a:noFill/>
@@ -7403,7 +7403,7 @@
             <a:avLst/>
           </a:prstGeom>
           <a:solidFill>
-            <a:srgbClr val="C8102E"/>
+            <a:srgbClr val="C41F3E"/>
           </a:solidFill>
           <a:ln>
             <a:noFill/>
@@ -7465,7 +7465,7 @@
             <a:r>
               <a:rPr sz="1050" b="1" i="0">
                 <a:solidFill>
-                  <a:srgbClr val="006D77"/>
+                  <a:srgbClr val="007BA4"/>
                 </a:solidFill>
                 <a:latin typeface="Segoe UI"/>
               </a:rPr>
@@ -7558,7 +7558,7 @@
                   </a:txBody>
                   <a:tcPr anchor="ctr" marL="91440">
                     <a:solidFill>
-                      <a:srgbClr val="006D77"/>
+                      <a:srgbClr val="007BA4"/>
                     </a:solidFill>
                   </a:tcPr>
                 </a:tc>
@@ -7580,7 +7580,7 @@
                   </a:txBody>
                   <a:tcPr anchor="ctr" marL="91440">
                     <a:solidFill>
-                      <a:srgbClr val="006D77"/>
+                      <a:srgbClr val="007BA4"/>
                     </a:solidFill>
                   </a:tcPr>
                 </a:tc>
@@ -7602,7 +7602,7 @@
                   </a:txBody>
                   <a:tcPr anchor="ctr" marL="91440">
                     <a:solidFill>
-                      <a:srgbClr val="006D77"/>
+                      <a:srgbClr val="007BA4"/>
                     </a:solidFill>
                   </a:tcPr>
                 </a:tc>
@@ -8041,7 +8041,7 @@
             <a:avLst/>
           </a:prstGeom>
           <a:solidFill>
-            <a:srgbClr val="006D77"/>
+            <a:srgbClr val="007BA4"/>
           </a:solidFill>
           <a:ln>
             <a:noFill/>
@@ -8187,7 +8187,7 @@
             <a:avLst/>
           </a:prstGeom>
           <a:solidFill>
-            <a:srgbClr val="C8102E"/>
+            <a:srgbClr val="C41F3E"/>
           </a:solidFill>
           <a:ln>
             <a:noFill/>
@@ -8249,7 +8249,7 @@
             <a:r>
               <a:rPr sz="1050" b="1" i="0">
                 <a:solidFill>
-                  <a:srgbClr val="006D77"/>
+                  <a:srgbClr val="007BA4"/>
                 </a:solidFill>
                 <a:latin typeface="Segoe UI"/>
               </a:rPr>
@@ -8342,7 +8342,7 @@
                   </a:txBody>
                   <a:tcPr anchor="ctr" marL="91440">
                     <a:solidFill>
-                      <a:srgbClr val="006D77"/>
+                      <a:srgbClr val="007BA4"/>
                     </a:solidFill>
                   </a:tcPr>
                 </a:tc>
@@ -8364,7 +8364,7 @@
                   </a:txBody>
                   <a:tcPr anchor="ctr" marL="91440">
                     <a:solidFill>
-                      <a:srgbClr val="006D77"/>
+                      <a:srgbClr val="007BA4"/>
                     </a:solidFill>
                   </a:tcPr>
                 </a:tc>
@@ -8386,7 +8386,7 @@
                   </a:txBody>
                   <a:tcPr anchor="ctr" marL="91440">
                     <a:solidFill>
-                      <a:srgbClr val="006D77"/>
+                      <a:srgbClr val="007BA4"/>
                     </a:solidFill>
                   </a:tcPr>
                 </a:tc>
@@ -9066,7 +9066,7 @@
             <a:avLst/>
           </a:prstGeom>
           <a:solidFill>
-            <a:srgbClr val="006D77"/>
+            <a:srgbClr val="007BA4"/>
           </a:solidFill>
           <a:ln>
             <a:noFill/>
@@ -9212,7 +9212,7 @@
             <a:avLst/>
           </a:prstGeom>
           <a:solidFill>
-            <a:srgbClr val="006D77"/>
+            <a:srgbClr val="005377"/>
           </a:solidFill>
           <a:ln>
             <a:noFill/>
@@ -9256,7 +9256,7 @@
             <a:avLst/>
           </a:prstGeom>
           <a:solidFill>
-            <a:srgbClr val="C8102E"/>
+            <a:srgbClr val="C41F3E"/>
           </a:solidFill>
           <a:ln>
             <a:noFill/>
@@ -9318,7 +9318,7 @@
             <a:r>
               <a:rPr sz="6400" b="1" i="0">
                 <a:solidFill>
-                  <a:srgbClr val="7FC4CB"/>
+                  <a:srgbClr val="A0D3E8"/>
                 </a:solidFill>
                 <a:latin typeface="Segoe UI"/>
               </a:rPr>
@@ -9402,7 +9402,7 @@
             <a:r>
               <a:rPr sz="1450" b="0" i="0">
                 <a:solidFill>
-                  <a:srgbClr val="D6ECEE"/>
+                  <a:srgbClr val="D3EDEE"/>
                 </a:solidFill>
                 <a:latin typeface="Segoe UI"/>
               </a:rPr>
@@ -9486,7 +9486,7 @@
             <a:avLst/>
           </a:prstGeom>
           <a:solidFill>
-            <a:srgbClr val="C8102E"/>
+            <a:srgbClr val="C41F3E"/>
           </a:solidFill>
           <a:ln>
             <a:noFill/>
@@ -9548,7 +9548,7 @@
             <a:r>
               <a:rPr sz="1050" b="1" i="0">
                 <a:solidFill>
-                  <a:srgbClr val="006D77"/>
+                  <a:srgbClr val="007BA4"/>
                 </a:solidFill>
                 <a:latin typeface="Segoe UI"/>
               </a:rPr>
@@ -9703,7 +9703,7 @@
                   </a:txBody>
                   <a:tcPr anchor="ctr" marL="91440">
                     <a:solidFill>
-                      <a:srgbClr val="006D77"/>
+                      <a:srgbClr val="007BA4"/>
                     </a:solidFill>
                   </a:tcPr>
                 </a:tc>
@@ -9725,7 +9725,7 @@
                   </a:txBody>
                   <a:tcPr anchor="ctr" marL="91440">
                     <a:solidFill>
-                      <a:srgbClr val="006D77"/>
+                      <a:srgbClr val="007BA4"/>
                     </a:solidFill>
                   </a:tcPr>
                 </a:tc>
@@ -9747,7 +9747,7 @@
                   </a:txBody>
                   <a:tcPr anchor="ctr" marL="91440">
                     <a:solidFill>
-                      <a:srgbClr val="006D77"/>
+                      <a:srgbClr val="007BA4"/>
                     </a:solidFill>
                   </a:tcPr>
                 </a:tc>
@@ -9769,7 +9769,7 @@
                   </a:txBody>
                   <a:tcPr anchor="ctr" marL="91440">
                     <a:solidFill>
-                      <a:srgbClr val="006D77"/>
+                      <a:srgbClr val="007BA4"/>
                     </a:solidFill>
                   </a:tcPr>
                 </a:tc>
@@ -10197,7 +10197,7 @@
             <a:avLst/>
           </a:prstGeom>
           <a:solidFill>
-            <a:srgbClr val="006D77"/>
+            <a:srgbClr val="007BA4"/>
           </a:solidFill>
           <a:ln>
             <a:noFill/>
@@ -10343,7 +10343,7 @@
             <a:avLst/>
           </a:prstGeom>
           <a:solidFill>
-            <a:srgbClr val="C8102E"/>
+            <a:srgbClr val="C41F3E"/>
           </a:solidFill>
           <a:ln>
             <a:noFill/>
@@ -10405,7 +10405,7 @@
             <a:r>
               <a:rPr sz="1050" b="1" i="0">
                 <a:solidFill>
-                  <a:srgbClr val="006D77"/>
+                  <a:srgbClr val="007BA4"/>
                 </a:solidFill>
                 <a:latin typeface="Segoe UI"/>
               </a:rPr>
@@ -10540,7 +10540,7 @@
                   </a:txBody>
                   <a:tcPr anchor="ctr" marL="91440">
                     <a:solidFill>
-                      <a:srgbClr val="006D77"/>
+                      <a:srgbClr val="007BA4"/>
                     </a:solidFill>
                   </a:tcPr>
                 </a:tc>
@@ -10562,7 +10562,7 @@
                   </a:txBody>
                   <a:tcPr anchor="ctr" marL="91440">
                     <a:solidFill>
-                      <a:srgbClr val="006D77"/>
+                      <a:srgbClr val="007BA4"/>
                     </a:solidFill>
                   </a:tcPr>
                 </a:tc>
@@ -10584,7 +10584,7 @@
                   </a:txBody>
                   <a:tcPr anchor="ctr" marL="91440">
                     <a:solidFill>
-                      <a:srgbClr val="006D77"/>
+                      <a:srgbClr val="007BA4"/>
                     </a:solidFill>
                   </a:tcPr>
                 </a:tc>
@@ -11139,7 +11139,7 @@
             <a:avLst/>
           </a:prstGeom>
           <a:solidFill>
-            <a:srgbClr val="C8102E"/>
+            <a:srgbClr val="C41F3E"/>
           </a:solidFill>
           <a:ln>
             <a:noFill/>
@@ -11201,7 +11201,7 @@
             <a:r>
               <a:rPr sz="1050" b="1" i="0">
                 <a:solidFill>
-                  <a:srgbClr val="006D77"/>
+                  <a:srgbClr val="007BA4"/>
                 </a:solidFill>
                 <a:latin typeface="Segoe UI"/>
               </a:rPr>
@@ -11295,7 +11295,7 @@
                   </a:txBody>
                   <a:tcPr anchor="ctr" marL="91440">
                     <a:solidFill>
-                      <a:srgbClr val="006D77"/>
+                      <a:srgbClr val="007BA4"/>
                     </a:solidFill>
                   </a:tcPr>
                 </a:tc>
@@ -11317,7 +11317,7 @@
                   </a:txBody>
                   <a:tcPr anchor="ctr" marL="91440">
                     <a:solidFill>
-                      <a:srgbClr val="006D77"/>
+                      <a:srgbClr val="007BA4"/>
                     </a:solidFill>
                   </a:tcPr>
                 </a:tc>
@@ -11339,7 +11339,7 @@
                   </a:txBody>
                   <a:tcPr anchor="ctr" marL="91440">
                     <a:solidFill>
-                      <a:srgbClr val="006D77"/>
+                      <a:srgbClr val="007BA4"/>
                     </a:solidFill>
                   </a:tcPr>
                 </a:tc>
@@ -11361,7 +11361,7 @@
                   </a:txBody>
                   <a:tcPr anchor="ctr" marL="91440">
                     <a:solidFill>
-                      <a:srgbClr val="006D77"/>
+                      <a:srgbClr val="007BA4"/>
                     </a:solidFill>
                   </a:tcPr>
                 </a:tc>
@@ -12329,7 +12329,7 @@
             <a:avLst/>
           </a:prstGeom>
           <a:solidFill>
-            <a:srgbClr val="006D77"/>
+            <a:srgbClr val="007BA4"/>
           </a:solidFill>
           <a:ln>
             <a:noFill/>
@@ -12475,7 +12475,7 @@
             <a:avLst/>
           </a:prstGeom>
           <a:solidFill>
-            <a:srgbClr val="C8102E"/>
+            <a:srgbClr val="C41F3E"/>
           </a:solidFill>
           <a:ln>
             <a:noFill/>
@@ -12860,7 +12860,7 @@
             <a:avLst/>
           </a:prstGeom>
           <a:solidFill>
-            <a:srgbClr val="006D77"/>
+            <a:srgbClr val="007BA4"/>
           </a:solidFill>
           <a:ln>
             <a:noFill/>
@@ -13006,7 +13006,7 @@
             <a:avLst/>
           </a:prstGeom>
           <a:solidFill>
-            <a:srgbClr val="C8102E"/>
+            <a:srgbClr val="C41F3E"/>
           </a:solidFill>
           <a:ln>
             <a:noFill/>
@@ -13068,7 +13068,7 @@
             <a:r>
               <a:rPr sz="1050" b="1" i="0">
                 <a:solidFill>
-                  <a:srgbClr val="006D77"/>
+                  <a:srgbClr val="007BA4"/>
                 </a:solidFill>
                 <a:latin typeface="Segoe UI"/>
               </a:rPr>
@@ -13161,7 +13161,7 @@
                   </a:txBody>
                   <a:tcPr anchor="ctr" marL="91440">
                     <a:solidFill>
-                      <a:srgbClr val="006D77"/>
+                      <a:srgbClr val="007BA4"/>
                     </a:solidFill>
                   </a:tcPr>
                 </a:tc>
@@ -13183,7 +13183,7 @@
                   </a:txBody>
                   <a:tcPr anchor="ctr" marL="91440">
                     <a:solidFill>
-                      <a:srgbClr val="006D77"/>
+                      <a:srgbClr val="007BA4"/>
                     </a:solidFill>
                   </a:tcPr>
                 </a:tc>
@@ -13205,7 +13205,7 @@
                   </a:txBody>
                   <a:tcPr anchor="ctr" marL="91440">
                     <a:solidFill>
-                      <a:srgbClr val="006D77"/>
+                      <a:srgbClr val="007BA4"/>
                     </a:solidFill>
                   </a:tcPr>
                 </a:tc>
@@ -14235,7 +14235,7 @@
             <a:avLst/>
           </a:prstGeom>
           <a:solidFill>
-            <a:srgbClr val="006D77"/>
+            <a:srgbClr val="005377"/>
           </a:solidFill>
           <a:ln>
             <a:noFill/>
@@ -14279,7 +14279,7 @@
             <a:avLst/>
           </a:prstGeom>
           <a:solidFill>
-            <a:srgbClr val="C8102E"/>
+            <a:srgbClr val="C41F3E"/>
           </a:solidFill>
           <a:ln>
             <a:noFill/>
@@ -14341,7 +14341,7 @@
             <a:r>
               <a:rPr sz="6400" b="1" i="0">
                 <a:solidFill>
-                  <a:srgbClr val="7FC4CB"/>
+                  <a:srgbClr val="A0D3E8"/>
                 </a:solidFill>
                 <a:latin typeface="Segoe UI"/>
               </a:rPr>
@@ -14425,7 +14425,7 @@
             <a:r>
               <a:rPr sz="1450" b="0" i="0">
                 <a:solidFill>
-                  <a:srgbClr val="D6ECEE"/>
+                  <a:srgbClr val="D3EDEE"/>
                 </a:solidFill>
                 <a:latin typeface="Segoe UI"/>
               </a:rPr>
@@ -14509,7 +14509,7 @@
             <a:avLst/>
           </a:prstGeom>
           <a:solidFill>
-            <a:srgbClr val="C8102E"/>
+            <a:srgbClr val="C41F3E"/>
           </a:solidFill>
           <a:ln>
             <a:noFill/>
@@ -14571,7 +14571,7 @@
             <a:r>
               <a:rPr sz="1050" b="1" i="0">
                 <a:solidFill>
-                  <a:srgbClr val="006D77"/>
+                  <a:srgbClr val="007BA4"/>
                 </a:solidFill>
                 <a:latin typeface="Segoe UI"/>
               </a:rPr>
@@ -15295,7 +15295,7 @@
             <a:avLst/>
           </a:prstGeom>
           <a:solidFill>
-            <a:srgbClr val="C8102E"/>
+            <a:srgbClr val="C41F3E"/>
           </a:solidFill>
           <a:ln>
             <a:noFill/>
@@ -15357,7 +15357,7 @@
             <a:r>
               <a:rPr sz="1050" b="1" i="0">
                 <a:solidFill>
-                  <a:srgbClr val="006D77"/>
+                  <a:srgbClr val="007BA4"/>
                 </a:solidFill>
                 <a:latin typeface="Segoe UI"/>
               </a:rPr>
@@ -15450,7 +15450,7 @@
                   </a:txBody>
                   <a:tcPr anchor="ctr" marL="91440">
                     <a:solidFill>
-                      <a:srgbClr val="006D77"/>
+                      <a:srgbClr val="007BA4"/>
                     </a:solidFill>
                   </a:tcPr>
                 </a:tc>
@@ -15472,7 +15472,7 @@
                   </a:txBody>
                   <a:tcPr anchor="ctr" marL="91440">
                     <a:solidFill>
-                      <a:srgbClr val="006D77"/>
+                      <a:srgbClr val="007BA4"/>
                     </a:solidFill>
                   </a:tcPr>
                 </a:tc>
@@ -15494,7 +15494,7 @@
                   </a:txBody>
                   <a:tcPr anchor="ctr" marL="91440">
                     <a:solidFill>
-                      <a:srgbClr val="006D77"/>
+                      <a:srgbClr val="007BA4"/>
                     </a:solidFill>
                   </a:tcPr>
                 </a:tc>
@@ -16116,7 +16116,7 @@
             <a:avLst/>
           </a:prstGeom>
           <a:solidFill>
-            <a:srgbClr val="006D77"/>
+            <a:srgbClr val="005377"/>
           </a:solidFill>
           <a:ln>
             <a:noFill/>
@@ -16160,7 +16160,7 @@
             <a:avLst/>
           </a:prstGeom>
           <a:solidFill>
-            <a:srgbClr val="C8102E"/>
+            <a:srgbClr val="C41F3E"/>
           </a:solidFill>
           <a:ln>
             <a:noFill/>
@@ -16222,7 +16222,7 @@
             <a:r>
               <a:rPr sz="6400" b="1" i="0">
                 <a:solidFill>
-                  <a:srgbClr val="7FC4CB"/>
+                  <a:srgbClr val="A0D3E8"/>
                 </a:solidFill>
                 <a:latin typeface="Segoe UI"/>
               </a:rPr>
@@ -16306,7 +16306,7 @@
             <a:r>
               <a:rPr sz="1450" b="0" i="0">
                 <a:solidFill>
-                  <a:srgbClr val="D6ECEE"/>
+                  <a:srgbClr val="D3EDEE"/>
                 </a:solidFill>
                 <a:latin typeface="Segoe UI"/>
               </a:rPr>
@@ -16390,7 +16390,7 @@
             <a:avLst/>
           </a:prstGeom>
           <a:solidFill>
-            <a:srgbClr val="C8102E"/>
+            <a:srgbClr val="C41F3E"/>
           </a:solidFill>
           <a:ln>
             <a:noFill/>
@@ -16452,7 +16452,7 @@
             <a:r>
               <a:rPr sz="1050" b="1" i="0">
                 <a:solidFill>
-                  <a:srgbClr val="006D77"/>
+                  <a:srgbClr val="007BA4"/>
                 </a:solidFill>
                 <a:latin typeface="Segoe UI"/>
               </a:rPr>
@@ -16545,7 +16545,7 @@
                   </a:txBody>
                   <a:tcPr anchor="ctr" marL="91440">
                     <a:solidFill>
-                      <a:srgbClr val="006D77"/>
+                      <a:srgbClr val="007BA4"/>
                     </a:solidFill>
                   </a:tcPr>
                 </a:tc>
@@ -16567,7 +16567,7 @@
                   </a:txBody>
                   <a:tcPr anchor="ctr" marL="91440">
                     <a:solidFill>
-                      <a:srgbClr val="006D77"/>
+                      <a:srgbClr val="007BA4"/>
                     </a:solidFill>
                   </a:tcPr>
                 </a:tc>
@@ -16589,7 +16589,7 @@
                   </a:txBody>
                   <a:tcPr anchor="ctr" marL="91440">
                     <a:solidFill>
-                      <a:srgbClr val="006D77"/>
+                      <a:srgbClr val="007BA4"/>
                     </a:solidFill>
                   </a:tcPr>
                 </a:tc>
@@ -17201,7 +17201,7 @@
             <a:avLst/>
           </a:prstGeom>
           <a:solidFill>
-            <a:srgbClr val="006D77"/>
+            <a:srgbClr val="007BA4"/>
           </a:solidFill>
           <a:ln>
             <a:noFill/>
@@ -17347,7 +17347,7 @@
             <a:avLst/>
           </a:prstGeom>
           <a:solidFill>
-            <a:srgbClr val="C8102E"/>
+            <a:srgbClr val="C41F3E"/>
           </a:solidFill>
           <a:ln>
             <a:noFill/>
@@ -17409,7 +17409,7 @@
             <a:r>
               <a:rPr sz="1050" b="1" i="0">
                 <a:solidFill>
-                  <a:srgbClr val="006D77"/>
+                  <a:srgbClr val="007BA4"/>
                 </a:solidFill>
                 <a:latin typeface="Segoe UI"/>
               </a:rPr>
@@ -17502,7 +17502,7 @@
                   </a:txBody>
                   <a:tcPr anchor="ctr" marL="91440">
                     <a:solidFill>
-                      <a:srgbClr val="006D77"/>
+                      <a:srgbClr val="007BA4"/>
                     </a:solidFill>
                   </a:tcPr>
                 </a:tc>
@@ -17524,7 +17524,7 @@
                   </a:txBody>
                   <a:tcPr anchor="ctr" marL="91440">
                     <a:solidFill>
-                      <a:srgbClr val="006D77"/>
+                      <a:srgbClr val="007BA4"/>
                     </a:solidFill>
                   </a:tcPr>
                 </a:tc>
@@ -17546,7 +17546,7 @@
                   </a:txBody>
                   <a:tcPr anchor="ctr" marL="91440">
                     <a:solidFill>
-                      <a:srgbClr val="006D77"/>
+                      <a:srgbClr val="007BA4"/>
                     </a:solidFill>
                   </a:tcPr>
                 </a:tc>
@@ -18158,7 +18158,7 @@
             <a:avLst/>
           </a:prstGeom>
           <a:solidFill>
-            <a:srgbClr val="006D77"/>
+            <a:srgbClr val="007BA4"/>
           </a:solidFill>
           <a:ln>
             <a:noFill/>
@@ -18304,7 +18304,7 @@
             <a:avLst/>
           </a:prstGeom>
           <a:solidFill>
-            <a:srgbClr val="006D77"/>
+            <a:srgbClr val="005377"/>
           </a:solidFill>
           <a:ln>
             <a:noFill/>
@@ -18348,7 +18348,7 @@
             <a:avLst/>
           </a:prstGeom>
           <a:solidFill>
-            <a:srgbClr val="C8102E"/>
+            <a:srgbClr val="C41F3E"/>
           </a:solidFill>
           <a:ln>
             <a:noFill/>
@@ -18410,7 +18410,7 @@
             <a:r>
               <a:rPr sz="6400" b="1" i="0">
                 <a:solidFill>
-                  <a:srgbClr val="7FC4CB"/>
+                  <a:srgbClr val="A0D3E8"/>
                 </a:solidFill>
                 <a:latin typeface="Segoe UI"/>
               </a:rPr>
@@ -18494,7 +18494,7 @@
             <a:r>
               <a:rPr sz="1450" b="0" i="0">
                 <a:solidFill>
-                  <a:srgbClr val="D6ECEE"/>
+                  <a:srgbClr val="D3EDEE"/>
                 </a:solidFill>
                 <a:latin typeface="Segoe UI"/>
               </a:rPr>
@@ -18578,7 +18578,7 @@
             <a:avLst/>
           </a:prstGeom>
           <a:solidFill>
-            <a:srgbClr val="C8102E"/>
+            <a:srgbClr val="C41F3E"/>
           </a:solidFill>
           <a:ln>
             <a:noFill/>
@@ -18640,7 +18640,7 @@
             <a:r>
               <a:rPr sz="1050" b="1" i="0">
                 <a:solidFill>
-                  <a:srgbClr val="006D77"/>
+                  <a:srgbClr val="007BA4"/>
                 </a:solidFill>
                 <a:latin typeface="Segoe UI"/>
               </a:rPr>
@@ -18733,7 +18733,7 @@
                   </a:txBody>
                   <a:tcPr anchor="ctr" marL="91440">
                     <a:solidFill>
-                      <a:srgbClr val="006D77"/>
+                      <a:srgbClr val="007BA4"/>
                     </a:solidFill>
                   </a:tcPr>
                 </a:tc>
@@ -18755,7 +18755,7 @@
                   </a:txBody>
                   <a:tcPr anchor="ctr" marL="91440">
                     <a:solidFill>
-                      <a:srgbClr val="006D77"/>
+                      <a:srgbClr val="007BA4"/>
                     </a:solidFill>
                   </a:tcPr>
                 </a:tc>
@@ -18777,7 +18777,7 @@
                   </a:txBody>
                   <a:tcPr anchor="ctr" marL="91440">
                     <a:solidFill>
-                      <a:srgbClr val="006D77"/>
+                      <a:srgbClr val="007BA4"/>
                     </a:solidFill>
                   </a:tcPr>
                 </a:tc>
@@ -19634,7 +19634,7 @@
             <a:avLst/>
           </a:prstGeom>
           <a:solidFill>
-            <a:srgbClr val="C8102E"/>
+            <a:srgbClr val="C41F3E"/>
           </a:solidFill>
           <a:ln>
             <a:noFill/>
@@ -19696,7 +19696,7 @@
             <a:r>
               <a:rPr sz="1050" b="1" i="0">
                 <a:solidFill>
-                  <a:srgbClr val="006D77"/>
+                  <a:srgbClr val="007BA4"/>
                 </a:solidFill>
                 <a:latin typeface="Segoe UI"/>
               </a:rPr>
@@ -19806,7 +19806,7 @@
             <a:avLst/>
           </a:prstGeom>
           <a:solidFill>
-            <a:srgbClr val="006D77"/>
+            <a:srgbClr val="007BA4"/>
           </a:solidFill>
           <a:ln>
             <a:noFill/>
@@ -19868,7 +19868,7 @@
             <a:r>
               <a:rPr sz="3000" b="1" i="0">
                 <a:solidFill>
-                  <a:srgbClr val="006D77"/>
+                  <a:srgbClr val="007BA4"/>
                 </a:solidFill>
                 <a:latin typeface="Segoe UI"/>
               </a:rPr>
@@ -19979,7 +19979,7 @@
             <a:avLst/>
           </a:prstGeom>
           <a:solidFill>
-            <a:srgbClr val="006D77"/>
+            <a:srgbClr val="007BA4"/>
           </a:solidFill>
           <a:ln>
             <a:noFill/>
@@ -20041,7 +20041,7 @@
             <a:r>
               <a:rPr sz="3000" b="1" i="0">
                 <a:solidFill>
-                  <a:srgbClr val="006D77"/>
+                  <a:srgbClr val="007BA4"/>
                 </a:solidFill>
                 <a:latin typeface="Segoe UI"/>
               </a:rPr>
@@ -20152,7 +20152,7 @@
             <a:avLst/>
           </a:prstGeom>
           <a:solidFill>
-            <a:srgbClr val="006D77"/>
+            <a:srgbClr val="007BA4"/>
           </a:solidFill>
           <a:ln>
             <a:noFill/>
@@ -20214,7 +20214,7 @@
             <a:r>
               <a:rPr sz="3000" b="1" i="0">
                 <a:solidFill>
-                  <a:srgbClr val="006D77"/>
+                  <a:srgbClr val="007BA4"/>
                 </a:solidFill>
                 <a:latin typeface="Segoe UI"/>
               </a:rPr>
@@ -20325,7 +20325,7 @@
             <a:avLst/>
           </a:prstGeom>
           <a:solidFill>
-            <a:srgbClr val="006D77"/>
+            <a:srgbClr val="007BA4"/>
           </a:solidFill>
           <a:ln>
             <a:noFill/>
@@ -20387,7 +20387,7 @@
             <a:r>
               <a:rPr sz="3000" b="1" i="0">
                 <a:solidFill>
-                  <a:srgbClr val="006D77"/>
+                  <a:srgbClr val="007BA4"/>
                 </a:solidFill>
                 <a:latin typeface="Segoe UI"/>
               </a:rPr>
@@ -20498,7 +20498,7 @@
             <a:avLst/>
           </a:prstGeom>
           <a:solidFill>
-            <a:srgbClr val="006D77"/>
+            <a:srgbClr val="007BA4"/>
           </a:solidFill>
           <a:ln>
             <a:noFill/>
@@ -20560,7 +20560,7 @@
             <a:r>
               <a:rPr sz="3000" b="1" i="0">
                 <a:solidFill>
-                  <a:srgbClr val="006D77"/>
+                  <a:srgbClr val="007BA4"/>
                 </a:solidFill>
                 <a:latin typeface="Segoe UI"/>
               </a:rPr>
@@ -20654,7 +20654,7 @@
                   </a:txBody>
                   <a:tcPr anchor="ctr" marL="91440">
                     <a:solidFill>
-                      <a:srgbClr val="006D77"/>
+                      <a:srgbClr val="007BA4"/>
                     </a:solidFill>
                   </a:tcPr>
                 </a:tc>
@@ -20676,7 +20676,7 @@
                   </a:txBody>
                   <a:tcPr anchor="ctr" marL="91440">
                     <a:solidFill>
-                      <a:srgbClr val="006D77"/>
+                      <a:srgbClr val="007BA4"/>
                     </a:solidFill>
                   </a:tcPr>
                 </a:tc>
@@ -20698,7 +20698,7 @@
                   </a:txBody>
                   <a:tcPr anchor="ctr" marL="91440">
                     <a:solidFill>
-                      <a:srgbClr val="006D77"/>
+                      <a:srgbClr val="007BA4"/>
                     </a:solidFill>
                   </a:tcPr>
                 </a:tc>
@@ -21252,7 +21252,7 @@
             <a:avLst/>
           </a:prstGeom>
           <a:solidFill>
-            <a:srgbClr val="006D77"/>
+            <a:srgbClr val="005377"/>
           </a:solidFill>
           <a:ln>
             <a:noFill/>
@@ -21296,7 +21296,7 @@
             <a:avLst/>
           </a:prstGeom>
           <a:solidFill>
-            <a:srgbClr val="C8102E"/>
+            <a:srgbClr val="C41F3E"/>
           </a:solidFill>
           <a:ln>
             <a:noFill/>
@@ -21358,7 +21358,7 @@
             <a:r>
               <a:rPr sz="6400" b="1" i="0">
                 <a:solidFill>
-                  <a:srgbClr val="7FC4CB"/>
+                  <a:srgbClr val="A0D3E8"/>
                 </a:solidFill>
                 <a:latin typeface="Segoe UI"/>
               </a:rPr>
@@ -21442,7 +21442,7 @@
             <a:r>
               <a:rPr sz="1450" b="0" i="0">
                 <a:solidFill>
-                  <a:srgbClr val="D6ECEE"/>
+                  <a:srgbClr val="D3EDEE"/>
                 </a:solidFill>
                 <a:latin typeface="Segoe UI"/>
               </a:rPr>
@@ -21526,7 +21526,7 @@
             <a:avLst/>
           </a:prstGeom>
           <a:solidFill>
-            <a:srgbClr val="C8102E"/>
+            <a:srgbClr val="C41F3E"/>
           </a:solidFill>
           <a:ln>
             <a:noFill/>
@@ -21588,7 +21588,7 @@
             <a:r>
               <a:rPr sz="1050" b="1" i="0">
                 <a:solidFill>
-                  <a:srgbClr val="006D77"/>
+                  <a:srgbClr val="007BA4"/>
                 </a:solidFill>
                 <a:latin typeface="Segoe UI"/>
               </a:rPr>
@@ -22019,7 +22019,7 @@
             <a:avLst/>
           </a:prstGeom>
           <a:solidFill>
-            <a:srgbClr val="C8102E"/>
+            <a:srgbClr val="C41F3E"/>
           </a:solidFill>
           <a:ln>
             <a:noFill/>
@@ -22081,7 +22081,7 @@
             <a:r>
               <a:rPr sz="1050" b="1" i="0">
                 <a:solidFill>
-                  <a:srgbClr val="006D77"/>
+                  <a:srgbClr val="007BA4"/>
                 </a:solidFill>
                 <a:latin typeface="Segoe UI"/>
               </a:rPr>
@@ -22191,7 +22191,7 @@
             <a:avLst/>
           </a:prstGeom>
           <a:solidFill>
-            <a:srgbClr val="006D77"/>
+            <a:srgbClr val="007BA4"/>
           </a:solidFill>
           <a:ln>
             <a:noFill/>
@@ -22253,7 +22253,7 @@
             <a:r>
               <a:rPr sz="3000" b="1" i="0">
                 <a:solidFill>
-                  <a:srgbClr val="006D77"/>
+                  <a:srgbClr val="007BA4"/>
                 </a:solidFill>
                 <a:latin typeface="Segoe UI"/>
               </a:rPr>
@@ -22364,7 +22364,7 @@
             <a:avLst/>
           </a:prstGeom>
           <a:solidFill>
-            <a:srgbClr val="006D77"/>
+            <a:srgbClr val="007BA4"/>
           </a:solidFill>
           <a:ln>
             <a:noFill/>
@@ -22426,7 +22426,7 @@
             <a:r>
               <a:rPr sz="3000" b="1" i="0">
                 <a:solidFill>
-                  <a:srgbClr val="006D77"/>
+                  <a:srgbClr val="007BA4"/>
                 </a:solidFill>
                 <a:latin typeface="Segoe UI"/>
               </a:rPr>
@@ -22537,7 +22537,7 @@
             <a:avLst/>
           </a:prstGeom>
           <a:solidFill>
-            <a:srgbClr val="006D77"/>
+            <a:srgbClr val="007BA4"/>
           </a:solidFill>
           <a:ln>
             <a:noFill/>
@@ -22599,7 +22599,7 @@
             <a:r>
               <a:rPr sz="3000" b="1" i="0">
                 <a:solidFill>
-                  <a:srgbClr val="006D77"/>
+                  <a:srgbClr val="007BA4"/>
                 </a:solidFill>
                 <a:latin typeface="Segoe UI"/>
               </a:rPr>
@@ -22710,7 +22710,7 @@
             <a:avLst/>
           </a:prstGeom>
           <a:solidFill>
-            <a:srgbClr val="006D77"/>
+            <a:srgbClr val="007BA4"/>
           </a:solidFill>
           <a:ln>
             <a:noFill/>
@@ -22772,7 +22772,7 @@
             <a:r>
               <a:rPr sz="3000" b="1" i="0">
                 <a:solidFill>
-                  <a:srgbClr val="006D77"/>
+                  <a:srgbClr val="007BA4"/>
                 </a:solidFill>
                 <a:latin typeface="Segoe UI"/>
               </a:rPr>
@@ -22866,7 +22866,7 @@
                   </a:txBody>
                   <a:tcPr anchor="ctr" marL="91440">
                     <a:solidFill>
-                      <a:srgbClr val="006D77"/>
+                      <a:srgbClr val="007BA4"/>
                     </a:solidFill>
                   </a:tcPr>
                 </a:tc>
@@ -22888,7 +22888,7 @@
                   </a:txBody>
                   <a:tcPr anchor="ctr" marL="91440">
                     <a:solidFill>
-                      <a:srgbClr val="006D77"/>
+                      <a:srgbClr val="007BA4"/>
                     </a:solidFill>
                   </a:tcPr>
                 </a:tc>
@@ -22910,7 +22910,7 @@
                   </a:txBody>
                   <a:tcPr anchor="ctr" marL="91440">
                     <a:solidFill>
-                      <a:srgbClr val="006D77"/>
+                      <a:srgbClr val="007BA4"/>
                     </a:solidFill>
                   </a:tcPr>
                 </a:tc>
@@ -23658,7 +23658,7 @@
             <a:avLst/>
           </a:prstGeom>
           <a:solidFill>
-            <a:srgbClr val="006D77"/>
+            <a:srgbClr val="007BA4"/>
           </a:solidFill>
           <a:ln>
             <a:noFill/>
@@ -23804,7 +23804,7 @@
             <a:avLst/>
           </a:prstGeom>
           <a:solidFill>
-            <a:srgbClr val="C8102E"/>
+            <a:srgbClr val="C41F3E"/>
           </a:solidFill>
           <a:ln>
             <a:noFill/>
@@ -23866,7 +23866,7 @@
             <a:r>
               <a:rPr sz="1050" b="1" i="0">
                 <a:solidFill>
-                  <a:srgbClr val="006D77"/>
+                  <a:srgbClr val="007BA4"/>
                 </a:solidFill>
                 <a:latin typeface="Segoe UI"/>
               </a:rPr>
@@ -24019,7 +24019,7 @@
                   </a:txBody>
                   <a:tcPr anchor="ctr" marL="91440">
                     <a:solidFill>
-                      <a:srgbClr val="006D77"/>
+                      <a:srgbClr val="007BA4"/>
                     </a:solidFill>
                   </a:tcPr>
                 </a:tc>
@@ -24041,7 +24041,7 @@
                   </a:txBody>
                   <a:tcPr anchor="ctr" marL="91440">
                     <a:solidFill>
-                      <a:srgbClr val="006D77"/>
+                      <a:srgbClr val="007BA4"/>
                     </a:solidFill>
                   </a:tcPr>
                 </a:tc>
@@ -24485,7 +24485,7 @@
             <a:avLst/>
           </a:prstGeom>
           <a:solidFill>
-            <a:srgbClr val="C8102E"/>
+            <a:srgbClr val="C41F3E"/>
           </a:solidFill>
           <a:ln>
             <a:noFill/>
@@ -24547,7 +24547,7 @@
             <a:r>
               <a:rPr sz="1050" b="1" i="0">
                 <a:solidFill>
-                  <a:srgbClr val="006D77"/>
+                  <a:srgbClr val="007BA4"/>
                 </a:solidFill>
                 <a:latin typeface="Segoe UI"/>
               </a:rPr>
@@ -24700,7 +24700,7 @@
                   </a:txBody>
                   <a:tcPr anchor="ctr" marL="91440">
                     <a:solidFill>
-                      <a:srgbClr val="006D77"/>
+                      <a:srgbClr val="007BA4"/>
                     </a:solidFill>
                   </a:tcPr>
                 </a:tc>
@@ -24722,7 +24722,7 @@
                   </a:txBody>
                   <a:tcPr anchor="ctr" marL="91440">
                     <a:solidFill>
-                      <a:srgbClr val="006D77"/>
+                      <a:srgbClr val="007BA4"/>
                     </a:solidFill>
                   </a:tcPr>
                 </a:tc>
@@ -25120,7 +25120,7 @@
             <a:avLst/>
           </a:prstGeom>
           <a:solidFill>
-            <a:srgbClr val="C8102E"/>
+            <a:srgbClr val="C41F3E"/>
           </a:solidFill>
           <a:ln>
             <a:noFill/>
@@ -25182,7 +25182,7 @@
             <a:r>
               <a:rPr sz="1050" b="1" i="0">
                 <a:solidFill>
-                  <a:srgbClr val="006D77"/>
+                  <a:srgbClr val="007BA4"/>
                 </a:solidFill>
                 <a:latin typeface="Segoe UI"/>
               </a:rPr>
@@ -25275,7 +25275,7 @@
                   </a:txBody>
                   <a:tcPr anchor="ctr" marL="91440">
                     <a:solidFill>
-                      <a:srgbClr val="006D77"/>
+                      <a:srgbClr val="007BA4"/>
                     </a:solidFill>
                   </a:tcPr>
                 </a:tc>
@@ -25297,7 +25297,7 @@
                   </a:txBody>
                   <a:tcPr anchor="ctr" marL="91440">
                     <a:solidFill>
-                      <a:srgbClr val="006D77"/>
+                      <a:srgbClr val="007BA4"/>
                     </a:solidFill>
                   </a:tcPr>
                 </a:tc>
@@ -25319,7 +25319,7 @@
                   </a:txBody>
                   <a:tcPr anchor="ctr" marL="91440">
                     <a:solidFill>
-                      <a:srgbClr val="006D77"/>
+                      <a:srgbClr val="007BA4"/>
                     </a:solidFill>
                   </a:tcPr>
                 </a:tc>
@@ -26077,7 +26077,7 @@
             <a:avLst/>
           </a:prstGeom>
           <a:solidFill>
-            <a:srgbClr val="006D77"/>
+            <a:srgbClr val="005377"/>
           </a:solidFill>
           <a:ln>
             <a:noFill/>
@@ -26121,7 +26121,7 @@
             <a:avLst/>
           </a:prstGeom>
           <a:solidFill>
-            <a:srgbClr val="C8102E"/>
+            <a:srgbClr val="C41F3E"/>
           </a:solidFill>
           <a:ln>
             <a:noFill/>
@@ -26183,7 +26183,7 @@
             <a:r>
               <a:rPr sz="6400" b="1" i="0">
                 <a:solidFill>
-                  <a:srgbClr val="7FC4CB"/>
+                  <a:srgbClr val="A0D3E8"/>
                 </a:solidFill>
                 <a:latin typeface="Segoe UI"/>
               </a:rPr>
@@ -26267,7 +26267,7 @@
             <a:r>
               <a:rPr sz="1450" b="0" i="0">
                 <a:solidFill>
-                  <a:srgbClr val="D6ECEE"/>
+                  <a:srgbClr val="D3EDEE"/>
                 </a:solidFill>
                 <a:latin typeface="Segoe UI"/>
               </a:rPr>
@@ -26351,7 +26351,7 @@
             <a:avLst/>
           </a:prstGeom>
           <a:solidFill>
-            <a:srgbClr val="C8102E"/>
+            <a:srgbClr val="C41F3E"/>
           </a:solidFill>
           <a:ln>
             <a:noFill/>
@@ -26413,7 +26413,7 @@
             <a:r>
               <a:rPr sz="1050" b="1" i="0">
                 <a:solidFill>
-                  <a:srgbClr val="006D77"/>
+                  <a:srgbClr val="007BA4"/>
                 </a:solidFill>
                 <a:latin typeface="Segoe UI"/>
               </a:rPr>
@@ -26523,7 +26523,7 @@
             <a:avLst/>
           </a:prstGeom>
           <a:solidFill>
-            <a:srgbClr val="006D77"/>
+            <a:srgbClr val="007BA4"/>
           </a:solidFill>
           <a:ln>
             <a:noFill/>
@@ -26585,7 +26585,7 @@
             <a:r>
               <a:rPr sz="3000" b="1" i="0">
                 <a:solidFill>
-                  <a:srgbClr val="006D77"/>
+                  <a:srgbClr val="007BA4"/>
                 </a:solidFill>
                 <a:latin typeface="Segoe UI"/>
               </a:rPr>
@@ -26695,7 +26695,7 @@
             <a:avLst/>
           </a:prstGeom>
           <a:solidFill>
-            <a:srgbClr val="006D77"/>
+            <a:srgbClr val="007BA4"/>
           </a:solidFill>
           <a:ln>
             <a:noFill/>
@@ -26757,7 +26757,7 @@
             <a:r>
               <a:rPr sz="3000" b="1" i="0">
                 <a:solidFill>
-                  <a:srgbClr val="006D77"/>
+                  <a:srgbClr val="007BA4"/>
                 </a:solidFill>
                 <a:latin typeface="Segoe UI"/>
               </a:rPr>
@@ -26867,7 +26867,7 @@
             <a:avLst/>
           </a:prstGeom>
           <a:solidFill>
-            <a:srgbClr val="006D77"/>
+            <a:srgbClr val="007BA4"/>
           </a:solidFill>
           <a:ln>
             <a:noFill/>
@@ -26929,7 +26929,7 @@
             <a:r>
               <a:rPr sz="3000" b="1" i="0">
                 <a:solidFill>
-                  <a:srgbClr val="006D77"/>
+                  <a:srgbClr val="007BA4"/>
                 </a:solidFill>
                 <a:latin typeface="Segoe UI"/>
               </a:rPr>
@@ -27039,7 +27039,7 @@
             <a:avLst/>
           </a:prstGeom>
           <a:solidFill>
-            <a:srgbClr val="006D77"/>
+            <a:srgbClr val="007BA4"/>
           </a:solidFill>
           <a:ln>
             <a:noFill/>
@@ -27101,7 +27101,7 @@
             <a:r>
               <a:rPr sz="3000" b="1" i="0">
                 <a:solidFill>
-                  <a:srgbClr val="006D77"/>
+                  <a:srgbClr val="007BA4"/>
                 </a:solidFill>
                 <a:latin typeface="Segoe UI"/>
               </a:rPr>
@@ -27198,7 +27198,7 @@
                   </a:txBody>
                   <a:tcPr anchor="ctr" marL="91440">
                     <a:solidFill>
-                      <a:srgbClr val="006D77"/>
+                      <a:srgbClr val="007BA4"/>
                     </a:solidFill>
                   </a:tcPr>
                 </a:tc>
@@ -27220,7 +27220,7 @@
                   </a:txBody>
                   <a:tcPr anchor="ctr" marL="91440">
                     <a:solidFill>
-                      <a:srgbClr val="006D77"/>
+                      <a:srgbClr val="007BA4"/>
                     </a:solidFill>
                   </a:tcPr>
                 </a:tc>
@@ -27242,7 +27242,7 @@
                   </a:txBody>
                   <a:tcPr anchor="ctr" marL="91440">
                     <a:solidFill>
-                      <a:srgbClr val="006D77"/>
+                      <a:srgbClr val="007BA4"/>
                     </a:solidFill>
                   </a:tcPr>
                 </a:tc>
@@ -27264,7 +27264,7 @@
                   </a:txBody>
                   <a:tcPr anchor="ctr" marL="91440">
                     <a:solidFill>
-                      <a:srgbClr val="006D77"/>
+                      <a:srgbClr val="007BA4"/>
                     </a:solidFill>
                   </a:tcPr>
                 </a:tc>
@@ -27286,7 +27286,7 @@
                   </a:txBody>
                   <a:tcPr anchor="ctr" marL="91440">
                     <a:solidFill>
-                      <a:srgbClr val="006D77"/>
+                      <a:srgbClr val="007BA4"/>
                     </a:solidFill>
                   </a:tcPr>
                 </a:tc>
@@ -27308,7 +27308,7 @@
                   </a:txBody>
                   <a:tcPr anchor="ctr" marL="91440">
                     <a:solidFill>
-                      <a:srgbClr val="006D77"/>
+                      <a:srgbClr val="007BA4"/>
                     </a:solidFill>
                   </a:tcPr>
                 </a:tc>
@@ -27330,7 +27330,7 @@
                   </a:txBody>
                   <a:tcPr anchor="ctr" marL="91440">
                     <a:solidFill>
-                      <a:srgbClr val="006D77"/>
+                      <a:srgbClr val="007BA4"/>
                     </a:solidFill>
                   </a:tcPr>
                 </a:tc>
@@ -28220,7 +28220,7 @@
             <a:avLst/>
           </a:prstGeom>
           <a:solidFill>
-            <a:srgbClr val="006D77"/>
+            <a:srgbClr val="007BA4"/>
           </a:solidFill>
           <a:ln>
             <a:noFill/>
@@ -28366,7 +28366,7 @@
             <a:avLst/>
           </a:prstGeom>
           <a:solidFill>
-            <a:srgbClr val="C8102E"/>
+            <a:srgbClr val="C41F3E"/>
           </a:solidFill>
           <a:ln>
             <a:noFill/>
@@ -28428,7 +28428,7 @@
             <a:r>
               <a:rPr sz="1050" b="1" i="0">
                 <a:solidFill>
-                  <a:srgbClr val="006D77"/>
+                  <a:srgbClr val="007BA4"/>
                 </a:solidFill>
                 <a:latin typeface="Segoe UI"/>
               </a:rPr>
@@ -28521,7 +28521,7 @@
                   </a:txBody>
                   <a:tcPr anchor="ctr" marL="91440">
                     <a:solidFill>
-                      <a:srgbClr val="006D77"/>
+                      <a:srgbClr val="007BA4"/>
                     </a:solidFill>
                   </a:tcPr>
                 </a:tc>
@@ -28543,7 +28543,7 @@
                   </a:txBody>
                   <a:tcPr anchor="ctr" marL="91440">
                     <a:solidFill>
-                      <a:srgbClr val="006D77"/>
+                      <a:srgbClr val="007BA4"/>
                     </a:solidFill>
                   </a:tcPr>
                 </a:tc>
@@ -28565,7 +28565,7 @@
                   </a:txBody>
                   <a:tcPr anchor="ctr" marL="91440">
                     <a:solidFill>
-                      <a:srgbClr val="006D77"/>
+                      <a:srgbClr val="007BA4"/>
                     </a:solidFill>
                   </a:tcPr>
                 </a:tc>
@@ -29316,7 +29316,7 @@
             <a:avLst/>
           </a:prstGeom>
           <a:solidFill>
-            <a:srgbClr val="C8102E"/>
+            <a:srgbClr val="C41F3E"/>
           </a:solidFill>
           <a:ln>
             <a:noFill/>
@@ -29378,7 +29378,7 @@
             <a:r>
               <a:rPr sz="1050" b="1" i="0">
                 <a:solidFill>
-                  <a:srgbClr val="006D77"/>
+                  <a:srgbClr val="007BA4"/>
                 </a:solidFill>
                 <a:latin typeface="Segoe UI"/>
               </a:rPr>
@@ -29471,7 +29471,7 @@
                   </a:txBody>
                   <a:tcPr anchor="ctr" marL="91440">
                     <a:solidFill>
-                      <a:srgbClr val="006D77"/>
+                      <a:srgbClr val="007BA4"/>
                     </a:solidFill>
                   </a:tcPr>
                 </a:tc>
@@ -29493,7 +29493,7 @@
                   </a:txBody>
                   <a:tcPr anchor="ctr" marL="91440">
                     <a:solidFill>
-                      <a:srgbClr val="006D77"/>
+                      <a:srgbClr val="007BA4"/>
                     </a:solidFill>
                   </a:tcPr>
                 </a:tc>
@@ -29515,7 +29515,7 @@
                   </a:txBody>
                   <a:tcPr anchor="ctr" marL="91440">
                     <a:solidFill>
-                      <a:srgbClr val="006D77"/>
+                      <a:srgbClr val="007BA4"/>
                     </a:solidFill>
                   </a:tcPr>
                 </a:tc>
@@ -30273,7 +30273,7 @@
             <a:avLst/>
           </a:prstGeom>
           <a:solidFill>
-            <a:srgbClr val="006D77"/>
+            <a:srgbClr val="005377"/>
           </a:solidFill>
           <a:ln>
             <a:noFill/>
@@ -30317,7 +30317,7 @@
             <a:avLst/>
           </a:prstGeom>
           <a:solidFill>
-            <a:srgbClr val="C8102E"/>
+            <a:srgbClr val="C41F3E"/>
           </a:solidFill>
           <a:ln>
             <a:noFill/>
@@ -30379,7 +30379,7 @@
             <a:r>
               <a:rPr sz="6400" b="1" i="0">
                 <a:solidFill>
-                  <a:srgbClr val="7FC4CB"/>
+                  <a:srgbClr val="A0D3E8"/>
                 </a:solidFill>
                 <a:latin typeface="Segoe UI"/>
               </a:rPr>
@@ -30463,7 +30463,7 @@
             <a:r>
               <a:rPr sz="1450" b="0" i="0">
                 <a:solidFill>
-                  <a:srgbClr val="D6ECEE"/>
+                  <a:srgbClr val="D3EDEE"/>
                 </a:solidFill>
                 <a:latin typeface="Segoe UI"/>
               </a:rPr>
@@ -30547,7 +30547,7 @@
             <a:avLst/>
           </a:prstGeom>
           <a:solidFill>
-            <a:srgbClr val="C8102E"/>
+            <a:srgbClr val="C41F3E"/>
           </a:solidFill>
           <a:ln>
             <a:noFill/>
@@ -30609,7 +30609,7 @@
             <a:r>
               <a:rPr sz="1050" b="1" i="0">
                 <a:solidFill>
-                  <a:srgbClr val="006D77"/>
+                  <a:srgbClr val="007BA4"/>
                 </a:solidFill>
                 <a:latin typeface="Segoe UI"/>
               </a:rPr>
@@ -30719,7 +30719,7 @@
             <a:avLst/>
           </a:prstGeom>
           <a:solidFill>
-            <a:srgbClr val="006D77"/>
+            <a:srgbClr val="007BA4"/>
           </a:solidFill>
           <a:ln>
             <a:noFill/>
@@ -30781,7 +30781,7 @@
             <a:r>
               <a:rPr sz="3000" b="1" i="0">
                 <a:solidFill>
-                  <a:srgbClr val="006D77"/>
+                  <a:srgbClr val="007BA4"/>
                 </a:solidFill>
                 <a:latin typeface="Segoe UI"/>
               </a:rPr>
@@ -30892,7 +30892,7 @@
             <a:avLst/>
           </a:prstGeom>
           <a:solidFill>
-            <a:srgbClr val="006D77"/>
+            <a:srgbClr val="007BA4"/>
           </a:solidFill>
           <a:ln>
             <a:noFill/>
@@ -30954,7 +30954,7 @@
             <a:r>
               <a:rPr sz="3000" b="1" i="0">
                 <a:solidFill>
-                  <a:srgbClr val="006D77"/>
+                  <a:srgbClr val="007BA4"/>
                 </a:solidFill>
                 <a:latin typeface="Segoe UI"/>
               </a:rPr>
@@ -31065,7 +31065,7 @@
             <a:avLst/>
           </a:prstGeom>
           <a:solidFill>
-            <a:srgbClr val="006D77"/>
+            <a:srgbClr val="007BA4"/>
           </a:solidFill>
           <a:ln>
             <a:noFill/>
@@ -31127,7 +31127,7 @@
             <a:r>
               <a:rPr sz="3000" b="1" i="0">
                 <a:solidFill>
-                  <a:srgbClr val="006D77"/>
+                  <a:srgbClr val="007BA4"/>
                 </a:solidFill>
                 <a:latin typeface="Segoe UI"/>
               </a:rPr>
@@ -31238,7 +31238,7 @@
             <a:avLst/>
           </a:prstGeom>
           <a:solidFill>
-            <a:srgbClr val="006D77"/>
+            <a:srgbClr val="007BA4"/>
           </a:solidFill>
           <a:ln>
             <a:noFill/>
@@ -31300,7 +31300,7 @@
             <a:r>
               <a:rPr sz="3000" b="1" i="0">
                 <a:solidFill>
-                  <a:srgbClr val="006D77"/>
+                  <a:srgbClr val="007BA4"/>
                 </a:solidFill>
                 <a:latin typeface="Segoe UI"/>
               </a:rPr>
@@ -31411,7 +31411,7 @@
             <a:avLst/>
           </a:prstGeom>
           <a:solidFill>
-            <a:srgbClr val="006D77"/>
+            <a:srgbClr val="007BA4"/>
           </a:solidFill>
           <a:ln>
             <a:noFill/>
@@ -31473,7 +31473,7 @@
             <a:r>
               <a:rPr sz="3000" b="1" i="0">
                 <a:solidFill>
-                  <a:srgbClr val="006D77"/>
+                  <a:srgbClr val="007BA4"/>
                 </a:solidFill>
                 <a:latin typeface="Segoe UI"/>
               </a:rPr>
@@ -31737,7 +31737,7 @@
             <a:avLst/>
           </a:prstGeom>
           <a:solidFill>
-            <a:srgbClr val="C8102E"/>
+            <a:srgbClr val="C41F3E"/>
           </a:solidFill>
           <a:ln>
             <a:noFill/>
@@ -31799,7 +31799,7 @@
             <a:r>
               <a:rPr sz="1050" b="1" i="0">
                 <a:solidFill>
-                  <a:srgbClr val="006D77"/>
+                  <a:srgbClr val="007BA4"/>
                 </a:solidFill>
                 <a:latin typeface="Segoe UI"/>
               </a:rPr>
@@ -31892,7 +31892,7 @@
                   </a:txBody>
                   <a:tcPr anchor="ctr" marL="91440">
                     <a:solidFill>
-                      <a:srgbClr val="006D77"/>
+                      <a:srgbClr val="007BA4"/>
                     </a:solidFill>
                   </a:tcPr>
                 </a:tc>
@@ -31914,7 +31914,7 @@
                   </a:txBody>
                   <a:tcPr anchor="ctr" marL="91440">
                     <a:solidFill>
-                      <a:srgbClr val="006D77"/>
+                      <a:srgbClr val="007BA4"/>
                     </a:solidFill>
                   </a:tcPr>
                 </a:tc>
@@ -31936,7 +31936,7 @@
                   </a:txBody>
                   <a:tcPr anchor="ctr" marL="91440">
                     <a:solidFill>
-                      <a:srgbClr val="006D77"/>
+                      <a:srgbClr val="007BA4"/>
                     </a:solidFill>
                   </a:tcPr>
                 </a:tc>
@@ -32927,7 +32927,7 @@
             <a:avLst/>
           </a:prstGeom>
           <a:solidFill>
-            <a:srgbClr val="006D77"/>
+            <a:srgbClr val="007BA4"/>
           </a:solidFill>
           <a:ln>
             <a:noFill/>
@@ -33073,7 +33073,7 @@
             <a:avLst/>
           </a:prstGeom>
           <a:solidFill>
-            <a:srgbClr val="C8102E"/>
+            <a:srgbClr val="C41F3E"/>
           </a:solidFill>
           <a:ln>
             <a:noFill/>
@@ -33135,7 +33135,7 @@
             <a:r>
               <a:rPr sz="1050" b="1" i="0">
                 <a:solidFill>
-                  <a:srgbClr val="006D77"/>
+                  <a:srgbClr val="007BA4"/>
                 </a:solidFill>
                 <a:latin typeface="Segoe UI"/>
               </a:rPr>
@@ -33229,7 +33229,7 @@
                   </a:txBody>
                   <a:tcPr anchor="ctr" marL="91440">
                     <a:solidFill>
-                      <a:srgbClr val="006D77"/>
+                      <a:srgbClr val="007BA4"/>
                     </a:solidFill>
                   </a:tcPr>
                 </a:tc>
@@ -33251,7 +33251,7 @@
                   </a:txBody>
                   <a:tcPr anchor="ctr" marL="91440">
                     <a:solidFill>
-                      <a:srgbClr val="006D77"/>
+                      <a:srgbClr val="007BA4"/>
                     </a:solidFill>
                   </a:tcPr>
                 </a:tc>
@@ -33273,7 +33273,7 @@
                   </a:txBody>
                   <a:tcPr anchor="ctr" marL="91440">
                     <a:solidFill>
-                      <a:srgbClr val="006D77"/>
+                      <a:srgbClr val="007BA4"/>
                     </a:solidFill>
                   </a:tcPr>
                 </a:tc>
@@ -33295,7 +33295,7 @@
                   </a:txBody>
                   <a:tcPr anchor="ctr" marL="91440">
                     <a:solidFill>
-                      <a:srgbClr val="006D77"/>
+                      <a:srgbClr val="007BA4"/>
                     </a:solidFill>
                   </a:tcPr>
                 </a:tc>
@@ -33993,7 +33993,7 @@
             <a:avLst/>
           </a:prstGeom>
           <a:solidFill>
-            <a:srgbClr val="006D77"/>
+            <a:srgbClr val="007BA4"/>
           </a:solidFill>
           <a:ln>
             <a:noFill/>
@@ -34139,7 +34139,7 @@
             <a:avLst/>
           </a:prstGeom>
           <a:solidFill>
-            <a:srgbClr val="C8102E"/>
+            <a:srgbClr val="C41F3E"/>
           </a:solidFill>
           <a:ln>
             <a:noFill/>
@@ -34201,7 +34201,7 @@
             <a:r>
               <a:rPr sz="1050" b="1" i="0">
                 <a:solidFill>
-                  <a:srgbClr val="006D77"/>
+                  <a:srgbClr val="007BA4"/>
                 </a:solidFill>
                 <a:latin typeface="Segoe UI"/>
               </a:rPr>
@@ -34295,7 +34295,7 @@
                   </a:txBody>
                   <a:tcPr anchor="ctr" marL="91440">
                     <a:solidFill>
-                      <a:srgbClr val="006D77"/>
+                      <a:srgbClr val="007BA4"/>
                     </a:solidFill>
                   </a:tcPr>
                 </a:tc>
@@ -34317,7 +34317,7 @@
                   </a:txBody>
                   <a:tcPr anchor="ctr" marL="91440">
                     <a:solidFill>
-                      <a:srgbClr val="006D77"/>
+                      <a:srgbClr val="007BA4"/>
                     </a:solidFill>
                   </a:tcPr>
                 </a:tc>
@@ -34339,7 +34339,7 @@
                   </a:txBody>
                   <a:tcPr anchor="ctr" marL="91440">
                     <a:solidFill>
-                      <a:srgbClr val="006D77"/>
+                      <a:srgbClr val="007BA4"/>
                     </a:solidFill>
                   </a:tcPr>
                 </a:tc>
@@ -34361,7 +34361,7 @@
                   </a:txBody>
                   <a:tcPr anchor="ctr" marL="91440">
                     <a:solidFill>
-                      <a:srgbClr val="006D77"/>
+                      <a:srgbClr val="007BA4"/>
                     </a:solidFill>
                   </a:tcPr>
                 </a:tc>
@@ -35205,7 +35205,7 @@
             <a:avLst/>
           </a:prstGeom>
           <a:solidFill>
-            <a:srgbClr val="006D77"/>
+            <a:srgbClr val="005377"/>
           </a:solidFill>
           <a:ln>
             <a:noFill/>
@@ -35249,7 +35249,7 @@
             <a:avLst/>
           </a:prstGeom>
           <a:solidFill>
-            <a:srgbClr val="C8102E"/>
+            <a:srgbClr val="C41F3E"/>
           </a:solidFill>
           <a:ln>
             <a:noFill/>
@@ -35311,7 +35311,7 @@
             <a:r>
               <a:rPr sz="6400" b="1" i="0">
                 <a:solidFill>
-                  <a:srgbClr val="7FC4CB"/>
+                  <a:srgbClr val="A0D3E8"/>
                 </a:solidFill>
                 <a:latin typeface="Segoe UI"/>
               </a:rPr>
@@ -35395,7 +35395,7 @@
             <a:r>
               <a:rPr sz="1450" b="0" i="0">
                 <a:solidFill>
-                  <a:srgbClr val="D6ECEE"/>
+                  <a:srgbClr val="D3EDEE"/>
                 </a:solidFill>
                 <a:latin typeface="Segoe UI"/>
               </a:rPr>
@@ -35479,7 +35479,7 @@
             <a:avLst/>
           </a:prstGeom>
           <a:solidFill>
-            <a:srgbClr val="C8102E"/>
+            <a:srgbClr val="C41F3E"/>
           </a:solidFill>
           <a:ln>
             <a:noFill/>
@@ -35541,7 +35541,7 @@
             <a:r>
               <a:rPr sz="1050" b="1" i="0">
                 <a:solidFill>
-                  <a:srgbClr val="006D77"/>
+                  <a:srgbClr val="007BA4"/>
                 </a:solidFill>
                 <a:latin typeface="Segoe UI"/>
               </a:rPr>
@@ -35788,7 +35788,7 @@
             <a:avLst/>
           </a:prstGeom>
           <a:solidFill>
-            <a:srgbClr val="006D77"/>
+            <a:srgbClr val="007BA4"/>
           </a:solidFill>
           <a:ln>
             <a:noFill/>
@@ -35934,7 +35934,7 @@
             <a:avLst/>
           </a:prstGeom>
           <a:solidFill>
-            <a:srgbClr val="C8102E"/>
+            <a:srgbClr val="C41F3E"/>
           </a:solidFill>
           <a:ln>
             <a:noFill/>
@@ -35996,7 +35996,7 @@
             <a:r>
               <a:rPr sz="1050" b="1" i="0">
                 <a:solidFill>
-                  <a:srgbClr val="006D77"/>
+                  <a:srgbClr val="007BA4"/>
                 </a:solidFill>
                 <a:latin typeface="Segoe UI"/>
               </a:rPr>
@@ -36090,7 +36090,7 @@
                   </a:txBody>
                   <a:tcPr anchor="ctr" marL="91440">
                     <a:solidFill>
-                      <a:srgbClr val="006D77"/>
+                      <a:srgbClr val="007BA4"/>
                     </a:solidFill>
                   </a:tcPr>
                 </a:tc>
@@ -36112,7 +36112,7 @@
                   </a:txBody>
                   <a:tcPr anchor="ctr" marL="91440">
                     <a:solidFill>
-                      <a:srgbClr val="006D77"/>
+                      <a:srgbClr val="007BA4"/>
                     </a:solidFill>
                   </a:tcPr>
                 </a:tc>
@@ -36134,7 +36134,7 @@
                   </a:txBody>
                   <a:tcPr anchor="ctr" marL="91440">
                     <a:solidFill>
-                      <a:srgbClr val="006D77"/>
+                      <a:srgbClr val="007BA4"/>
                     </a:solidFill>
                   </a:tcPr>
                 </a:tc>
@@ -36156,7 +36156,7 @@
                   </a:txBody>
                   <a:tcPr anchor="ctr" marL="91440">
                     <a:solidFill>
-                      <a:srgbClr val="006D77"/>
+                      <a:srgbClr val="007BA4"/>
                     </a:solidFill>
                   </a:tcPr>
                 </a:tc>
@@ -36764,7 +36764,7 @@
             <a:avLst/>
           </a:prstGeom>
           <a:solidFill>
-            <a:srgbClr val="006D77"/>
+            <a:srgbClr val="007BA4"/>
           </a:solidFill>
           <a:ln>
             <a:noFill/>
@@ -36910,7 +36910,7 @@
             <a:avLst/>
           </a:prstGeom>
           <a:solidFill>
-            <a:srgbClr val="C8102E"/>
+            <a:srgbClr val="C41F3E"/>
           </a:solidFill>
           <a:ln>
             <a:noFill/>
@@ -36972,7 +36972,7 @@
             <a:r>
               <a:rPr sz="1050" b="1" i="0">
                 <a:solidFill>
-                  <a:srgbClr val="006D77"/>
+                  <a:srgbClr val="007BA4"/>
                 </a:solidFill>
                 <a:latin typeface="Segoe UI"/>
               </a:rPr>
@@ -37065,7 +37065,7 @@
                   </a:txBody>
                   <a:tcPr anchor="ctr" marL="91440">
                     <a:solidFill>
-                      <a:srgbClr val="006D77"/>
+                      <a:srgbClr val="007BA4"/>
                     </a:solidFill>
                   </a:tcPr>
                 </a:tc>
@@ -37087,7 +37087,7 @@
                   </a:txBody>
                   <a:tcPr anchor="ctr" marL="91440">
                     <a:solidFill>
-                      <a:srgbClr val="006D77"/>
+                      <a:srgbClr val="007BA4"/>
                     </a:solidFill>
                   </a:tcPr>
                 </a:tc>
@@ -37109,7 +37109,7 @@
                   </a:txBody>
                   <a:tcPr anchor="ctr" marL="91440">
                     <a:solidFill>
-                      <a:srgbClr val="006D77"/>
+                      <a:srgbClr val="007BA4"/>
                     </a:solidFill>
                   </a:tcPr>
                 </a:tc>
@@ -37700,7 +37700,7 @@
             <a:avLst/>
           </a:prstGeom>
           <a:solidFill>
-            <a:srgbClr val="C8102E"/>
+            <a:srgbClr val="C41F3E"/>
           </a:solidFill>
           <a:ln>
             <a:noFill/>
@@ -37762,7 +37762,7 @@
             <a:r>
               <a:rPr sz="1050" b="1" i="0">
                 <a:solidFill>
-                  <a:srgbClr val="006D77"/>
+                  <a:srgbClr val="007BA4"/>
                 </a:solidFill>
                 <a:latin typeface="Segoe UI"/>
               </a:rPr>
@@ -37854,7 +37854,7 @@
                   </a:txBody>
                   <a:tcPr anchor="ctr" marL="91440">
                     <a:solidFill>
-                      <a:srgbClr val="006D77"/>
+                      <a:srgbClr val="007BA4"/>
                     </a:solidFill>
                   </a:tcPr>
                 </a:tc>
@@ -37876,7 +37876,7 @@
                   </a:txBody>
                   <a:tcPr anchor="ctr" marL="91440">
                     <a:solidFill>
-                      <a:srgbClr val="006D77"/>
+                      <a:srgbClr val="007BA4"/>
                     </a:solidFill>
                   </a:tcPr>
                 </a:tc>
@@ -38312,7 +38312,7 @@
             <a:avLst/>
           </a:prstGeom>
           <a:solidFill>
-            <a:srgbClr val="006D77"/>
+            <a:srgbClr val="007BA4"/>
           </a:solidFill>
           <a:ln>
             <a:noFill/>
@@ -38458,7 +38458,7 @@
             <a:avLst/>
           </a:prstGeom>
           <a:solidFill>
-            <a:srgbClr val="C8102E"/>
+            <a:srgbClr val="C41F3E"/>
           </a:solidFill>
           <a:ln>
             <a:noFill/>
@@ -38520,7 +38520,7 @@
             <a:r>
               <a:rPr sz="1050" b="1" i="0">
                 <a:solidFill>
-                  <a:srgbClr val="006D77"/>
+                  <a:srgbClr val="007BA4"/>
                 </a:solidFill>
                 <a:latin typeface="Segoe UI"/>
               </a:rPr>
@@ -38824,7 +38824,7 @@
             <a:avLst/>
           </a:prstGeom>
           <a:solidFill>
-            <a:srgbClr val="006D77"/>
+            <a:srgbClr val="007BA4"/>
           </a:solidFill>
           <a:ln>
             <a:noFill/>
@@ -38970,7 +38970,7 @@
             <a:avLst/>
           </a:prstGeom>
           <a:solidFill>
-            <a:srgbClr val="006D77"/>
+            <a:srgbClr val="005377"/>
           </a:solidFill>
           <a:ln>
             <a:noFill/>
@@ -39014,7 +39014,7 @@
             <a:avLst/>
           </a:prstGeom>
           <a:solidFill>
-            <a:srgbClr val="C8102E"/>
+            <a:srgbClr val="C41F3E"/>
           </a:solidFill>
           <a:ln>
             <a:noFill/>
@@ -39076,7 +39076,7 @@
             <a:r>
               <a:rPr sz="6400" b="1" i="0">
                 <a:solidFill>
-                  <a:srgbClr val="7FC4CB"/>
+                  <a:srgbClr val="A0D3E8"/>
                 </a:solidFill>
                 <a:latin typeface="Segoe UI"/>
               </a:rPr>
@@ -39160,7 +39160,7 @@
             <a:r>
               <a:rPr sz="1450" b="0" i="0">
                 <a:solidFill>
-                  <a:srgbClr val="D6ECEE"/>
+                  <a:srgbClr val="D3EDEE"/>
                 </a:solidFill>
                 <a:latin typeface="Segoe UI"/>
               </a:rPr>
@@ -39244,7 +39244,7 @@
             <a:avLst/>
           </a:prstGeom>
           <a:solidFill>
-            <a:srgbClr val="C8102E"/>
+            <a:srgbClr val="C41F3E"/>
           </a:solidFill>
           <a:ln>
             <a:noFill/>
@@ -39306,7 +39306,7 @@
             <a:r>
               <a:rPr sz="1050" b="1" i="0">
                 <a:solidFill>
-                  <a:srgbClr val="006D77"/>
+                  <a:srgbClr val="007BA4"/>
                 </a:solidFill>
                 <a:latin typeface="Segoe UI"/>
               </a:rPr>
@@ -39497,7 +39497,7 @@
                   </a:txBody>
                   <a:tcPr anchor="ctr" marL="91440">
                     <a:solidFill>
-                      <a:srgbClr val="006D77"/>
+                      <a:srgbClr val="007BA4"/>
                     </a:solidFill>
                   </a:tcPr>
                 </a:tc>
@@ -39519,7 +39519,7 @@
                   </a:txBody>
                   <a:tcPr anchor="ctr" marL="91440">
                     <a:solidFill>
-                      <a:srgbClr val="006D77"/>
+                      <a:srgbClr val="007BA4"/>
                     </a:solidFill>
                   </a:tcPr>
                 </a:tc>
@@ -39863,7 +39863,7 @@
             <a:avLst/>
           </a:prstGeom>
           <a:solidFill>
-            <a:srgbClr val="006D77"/>
+            <a:srgbClr val="007BA4"/>
           </a:solidFill>
           <a:ln>
             <a:noFill/>
@@ -40009,7 +40009,7 @@
             <a:avLst/>
           </a:prstGeom>
           <a:solidFill>
-            <a:srgbClr val="C8102E"/>
+            <a:srgbClr val="C41F3E"/>
           </a:solidFill>
           <a:ln>
             <a:noFill/>
@@ -40071,7 +40071,7 @@
             <a:r>
               <a:rPr sz="1050" b="1" i="0">
                 <a:solidFill>
-                  <a:srgbClr val="006D77"/>
+                  <a:srgbClr val="007BA4"/>
                 </a:solidFill>
                 <a:latin typeface="Segoe UI"/>
               </a:rPr>
@@ -40166,7 +40166,7 @@
                   </a:txBody>
                   <a:tcPr anchor="ctr" marL="91440">
                     <a:solidFill>
-                      <a:srgbClr val="006D77"/>
+                      <a:srgbClr val="007BA4"/>
                     </a:solidFill>
                   </a:tcPr>
                 </a:tc>
@@ -40188,7 +40188,7 @@
                   </a:txBody>
                   <a:tcPr anchor="ctr" marL="91440">
                     <a:solidFill>
-                      <a:srgbClr val="006D77"/>
+                      <a:srgbClr val="007BA4"/>
                     </a:solidFill>
                   </a:tcPr>
                 </a:tc>
@@ -40210,7 +40210,7 @@
                   </a:txBody>
                   <a:tcPr anchor="ctr" marL="91440">
                     <a:solidFill>
-                      <a:srgbClr val="006D77"/>
+                      <a:srgbClr val="007BA4"/>
                     </a:solidFill>
                   </a:tcPr>
                 </a:tc>
@@ -40232,7 +40232,7 @@
                   </a:txBody>
                   <a:tcPr anchor="ctr" marL="91440">
                     <a:solidFill>
-                      <a:srgbClr val="006D77"/>
+                      <a:srgbClr val="007BA4"/>
                     </a:solidFill>
                   </a:tcPr>
                 </a:tc>
@@ -40254,7 +40254,7 @@
                   </a:txBody>
                   <a:tcPr anchor="ctr" marL="91440">
                     <a:solidFill>
-                      <a:srgbClr val="006D77"/>
+                      <a:srgbClr val="007BA4"/>
                     </a:solidFill>
                   </a:tcPr>
                 </a:tc>
@@ -41442,7 +41442,7 @@
             <a:avLst/>
           </a:prstGeom>
           <a:solidFill>
-            <a:srgbClr val="006D77"/>
+            <a:srgbClr val="007BA4"/>
           </a:solidFill>
           <a:ln>
             <a:noFill/>
@@ -41588,7 +41588,7 @@
             <a:avLst/>
           </a:prstGeom>
           <a:solidFill>
-            <a:srgbClr val="C8102E"/>
+            <a:srgbClr val="C41F3E"/>
           </a:solidFill>
           <a:ln>
             <a:noFill/>
@@ -41650,7 +41650,7 @@
             <a:r>
               <a:rPr sz="1050" b="1" i="0">
                 <a:solidFill>
-                  <a:srgbClr val="006D77"/>
+                  <a:srgbClr val="007BA4"/>
                 </a:solidFill>
                 <a:latin typeface="Segoe UI"/>
               </a:rPr>
@@ -41745,7 +41745,7 @@
                   </a:txBody>
                   <a:tcPr anchor="ctr" marL="91440">
                     <a:solidFill>
-                      <a:srgbClr val="006D77"/>
+                      <a:srgbClr val="007BA4"/>
                     </a:solidFill>
                   </a:tcPr>
                 </a:tc>
@@ -41767,7 +41767,7 @@
                   </a:txBody>
                   <a:tcPr anchor="ctr" marL="91440">
                     <a:solidFill>
-                      <a:srgbClr val="006D77"/>
+                      <a:srgbClr val="007BA4"/>
                     </a:solidFill>
                   </a:tcPr>
                 </a:tc>
@@ -41789,7 +41789,7 @@
                   </a:txBody>
                   <a:tcPr anchor="ctr" marL="91440">
                     <a:solidFill>
-                      <a:srgbClr val="006D77"/>
+                      <a:srgbClr val="007BA4"/>
                     </a:solidFill>
                   </a:tcPr>
                 </a:tc>
@@ -41811,7 +41811,7 @@
                   </a:txBody>
                   <a:tcPr anchor="ctr" marL="91440">
                     <a:solidFill>
-                      <a:srgbClr val="006D77"/>
+                      <a:srgbClr val="007BA4"/>
                     </a:solidFill>
                   </a:tcPr>
                 </a:tc>
@@ -41833,7 +41833,7 @@
                   </a:txBody>
                   <a:tcPr anchor="ctr" marL="91440">
                     <a:solidFill>
-                      <a:srgbClr val="006D77"/>
+                      <a:srgbClr val="007BA4"/>
                     </a:solidFill>
                   </a:tcPr>
                 </a:tc>
@@ -42502,7 +42502,7 @@
             <a:avLst/>
           </a:prstGeom>
           <a:solidFill>
-            <a:srgbClr val="C8102E"/>
+            <a:srgbClr val="C41F3E"/>
           </a:solidFill>
           <a:ln>
             <a:noFill/>
@@ -42564,7 +42564,7 @@
             <a:r>
               <a:rPr sz="1050" b="1" i="0">
                 <a:solidFill>
-                  <a:srgbClr val="006D77"/>
+                  <a:srgbClr val="007BA4"/>
                 </a:solidFill>
                 <a:latin typeface="Segoe UI"/>
               </a:rPr>
@@ -42657,7 +42657,7 @@
                   </a:txBody>
                   <a:tcPr anchor="ctr" marL="91440">
                     <a:solidFill>
-                      <a:srgbClr val="006D77"/>
+                      <a:srgbClr val="007BA4"/>
                     </a:solidFill>
                   </a:tcPr>
                 </a:tc>
@@ -42679,7 +42679,7 @@
                   </a:txBody>
                   <a:tcPr anchor="ctr" marL="91440">
                     <a:solidFill>
-                      <a:srgbClr val="006D77"/>
+                      <a:srgbClr val="007BA4"/>
                     </a:solidFill>
                   </a:tcPr>
                 </a:tc>
@@ -42701,7 +42701,7 @@
                   </a:txBody>
                   <a:tcPr anchor="ctr" marL="91440">
                     <a:solidFill>
-                      <a:srgbClr val="006D77"/>
+                      <a:srgbClr val="007BA4"/>
                     </a:solidFill>
                   </a:tcPr>
                 </a:tc>
@@ -43526,7 +43526,7 @@
             <a:avLst/>
           </a:prstGeom>
           <a:solidFill>
-            <a:srgbClr val="C8102E"/>
+            <a:srgbClr val="C41F3E"/>
           </a:solidFill>
           <a:ln>
             <a:noFill/>
@@ -43588,7 +43588,7 @@
             <a:r>
               <a:rPr sz="1050" b="1" i="0">
                 <a:solidFill>
-                  <a:srgbClr val="006D77"/>
+                  <a:srgbClr val="007BA4"/>
                 </a:solidFill>
                 <a:latin typeface="Segoe UI"/>
               </a:rPr>
@@ -43681,7 +43681,7 @@
                   </a:txBody>
                   <a:tcPr anchor="ctr" marL="91440">
                     <a:solidFill>
-                      <a:srgbClr val="006D77"/>
+                      <a:srgbClr val="007BA4"/>
                     </a:solidFill>
                   </a:tcPr>
                 </a:tc>
@@ -43703,7 +43703,7 @@
                   </a:txBody>
                   <a:tcPr anchor="ctr" marL="91440">
                     <a:solidFill>
-                      <a:srgbClr val="006D77"/>
+                      <a:srgbClr val="007BA4"/>
                     </a:solidFill>
                   </a:tcPr>
                 </a:tc>
@@ -43725,7 +43725,7 @@
                   </a:txBody>
                   <a:tcPr anchor="ctr" marL="91440">
                     <a:solidFill>
-                      <a:srgbClr val="006D77"/>
+                      <a:srgbClr val="007BA4"/>
                     </a:solidFill>
                   </a:tcPr>
                 </a:tc>
@@ -44353,7 +44353,7 @@
             <a:avLst/>
           </a:prstGeom>
           <a:solidFill>
-            <a:srgbClr val="006D77"/>
+            <a:srgbClr val="005377"/>
           </a:solidFill>
           <a:ln>
             <a:noFill/>
@@ -44397,7 +44397,7 @@
             <a:avLst/>
           </a:prstGeom>
           <a:solidFill>
-            <a:srgbClr val="C8102E"/>
+            <a:srgbClr val="C41F3E"/>
           </a:solidFill>
           <a:ln>
             <a:noFill/>
@@ -44501,7 +44501,7 @@
             <a:r>
               <a:rPr sz="1500" b="0" i="0">
                 <a:solidFill>
-                  <a:srgbClr val="D6ECEE"/>
+                  <a:srgbClr val="D3EDEE"/>
                 </a:solidFill>
                 <a:latin typeface="Segoe UI"/>
               </a:rPr>
@@ -44520,7 +44520,7 @@
             <a:r>
               <a:rPr sz="1300" b="0" i="0">
                 <a:solidFill>
-                  <a:srgbClr val="BFDFE3"/>
+                  <a:srgbClr val="A0D3E8"/>
                 </a:solidFill>
                 <a:latin typeface="Segoe UI"/>
               </a:rPr>
@@ -44604,7 +44604,7 @@
             <a:avLst/>
           </a:prstGeom>
           <a:solidFill>
-            <a:srgbClr val="C8102E"/>
+            <a:srgbClr val="C41F3E"/>
           </a:solidFill>
           <a:ln>
             <a:noFill/>
@@ -44666,7 +44666,7 @@
             <a:r>
               <a:rPr sz="1050" b="1" i="0">
                 <a:solidFill>
-                  <a:srgbClr val="006D77"/>
+                  <a:srgbClr val="007BA4"/>
                 </a:solidFill>
                 <a:latin typeface="Segoe UI"/>
               </a:rPr>
@@ -44759,7 +44759,7 @@
                   </a:txBody>
                   <a:tcPr anchor="ctr" marL="91440">
                     <a:solidFill>
-                      <a:srgbClr val="006D77"/>
+                      <a:srgbClr val="007BA4"/>
                     </a:solidFill>
                   </a:tcPr>
                 </a:tc>
@@ -44781,7 +44781,7 @@
                   </a:txBody>
                   <a:tcPr anchor="ctr" marL="91440">
                     <a:solidFill>
-                      <a:srgbClr val="006D77"/>
+                      <a:srgbClr val="007BA4"/>
                     </a:solidFill>
                   </a:tcPr>
                 </a:tc>
@@ -44803,7 +44803,7 @@
                   </a:txBody>
                   <a:tcPr anchor="ctr" marL="91440">
                     <a:solidFill>
-                      <a:srgbClr val="006D77"/>
+                      <a:srgbClr val="007BA4"/>
                     </a:solidFill>
                   </a:tcPr>
                 </a:tc>
@@ -45279,7 +45279,7 @@
             <a:avLst/>
           </a:prstGeom>
           <a:solidFill>
-            <a:srgbClr val="006D77"/>
+            <a:srgbClr val="007BA4"/>
           </a:solidFill>
           <a:ln>
             <a:noFill/>
@@ -45425,7 +45425,7 @@
             <a:avLst/>
           </a:prstGeom>
           <a:solidFill>
-            <a:srgbClr val="C8102E"/>
+            <a:srgbClr val="C41F3E"/>
           </a:solidFill>
           <a:ln>
             <a:noFill/>
@@ -45487,7 +45487,7 @@
             <a:r>
               <a:rPr sz="1050" b="1" i="0">
                 <a:solidFill>
-                  <a:srgbClr val="006D77"/>
+                  <a:srgbClr val="007BA4"/>
                 </a:solidFill>
                 <a:latin typeface="Segoe UI"/>
               </a:rPr>
@@ -45864,7 +45864,7 @@
             <a:avLst/>
           </a:prstGeom>
           <a:solidFill>
-            <a:srgbClr val="006D77"/>
+            <a:srgbClr val="005377"/>
           </a:solidFill>
           <a:ln>
             <a:noFill/>
@@ -45908,7 +45908,7 @@
             <a:avLst/>
           </a:prstGeom>
           <a:solidFill>
-            <a:srgbClr val="C8102E"/>
+            <a:srgbClr val="C41F3E"/>
           </a:solidFill>
           <a:ln>
             <a:noFill/>
@@ -45970,7 +45970,7 @@
             <a:r>
               <a:rPr sz="6400" b="1" i="0">
                 <a:solidFill>
-                  <a:srgbClr val="7FC4CB"/>
+                  <a:srgbClr val="A0D3E8"/>
                 </a:solidFill>
                 <a:latin typeface="Segoe UI"/>
               </a:rPr>
@@ -46054,7 +46054,7 @@
             <a:r>
               <a:rPr sz="1450" b="0" i="0">
                 <a:solidFill>
-                  <a:srgbClr val="D6ECEE"/>
+                  <a:srgbClr val="D3EDEE"/>
                 </a:solidFill>
                 <a:latin typeface="Segoe UI"/>
               </a:rPr>
@@ -46138,7 +46138,7 @@
             <a:avLst/>
           </a:prstGeom>
           <a:solidFill>
-            <a:srgbClr val="C8102E"/>
+            <a:srgbClr val="C41F3E"/>
           </a:solidFill>
           <a:ln>
             <a:noFill/>
@@ -46200,7 +46200,7 @@
             <a:r>
               <a:rPr sz="1050" b="1" i="0">
                 <a:solidFill>
-                  <a:srgbClr val="006D77"/>
+                  <a:srgbClr val="007BA4"/>
                 </a:solidFill>
                 <a:latin typeface="Segoe UI"/>
               </a:rPr>
@@ -46310,7 +46310,7 @@
             <a:avLst/>
           </a:prstGeom>
           <a:solidFill>
-            <a:srgbClr val="006D77"/>
+            <a:srgbClr val="007BA4"/>
           </a:solidFill>
           <a:ln>
             <a:noFill/>
@@ -46372,7 +46372,7 @@
             <a:r>
               <a:rPr sz="3000" b="1" i="0">
                 <a:solidFill>
-                  <a:srgbClr val="006D77"/>
+                  <a:srgbClr val="007BA4"/>
                 </a:solidFill>
                 <a:latin typeface="Segoe UI"/>
               </a:rPr>
@@ -46483,7 +46483,7 @@
             <a:avLst/>
           </a:prstGeom>
           <a:solidFill>
-            <a:srgbClr val="006D77"/>
+            <a:srgbClr val="007BA4"/>
           </a:solidFill>
           <a:ln>
             <a:noFill/>
@@ -46545,7 +46545,7 @@
             <a:r>
               <a:rPr sz="3000" b="1" i="0">
                 <a:solidFill>
-                  <a:srgbClr val="006D77"/>
+                  <a:srgbClr val="007BA4"/>
                 </a:solidFill>
                 <a:latin typeface="Segoe UI"/>
               </a:rPr>
@@ -46655,7 +46655,7 @@
             <a:avLst/>
           </a:prstGeom>
           <a:solidFill>
-            <a:srgbClr val="006D77"/>
+            <a:srgbClr val="007BA4"/>
           </a:solidFill>
           <a:ln>
             <a:noFill/>
@@ -46717,7 +46717,7 @@
             <a:r>
               <a:rPr sz="3000" b="1" i="0">
                 <a:solidFill>
-                  <a:srgbClr val="006D77"/>
+                  <a:srgbClr val="007BA4"/>
                 </a:solidFill>
                 <a:latin typeface="Segoe UI"/>
               </a:rPr>
@@ -46827,7 +46827,7 @@
             <a:avLst/>
           </a:prstGeom>
           <a:solidFill>
-            <a:srgbClr val="006D77"/>
+            <a:srgbClr val="007BA4"/>
           </a:solidFill>
           <a:ln>
             <a:noFill/>
@@ -46889,7 +46889,7 @@
             <a:r>
               <a:rPr sz="3000" b="1" i="0">
                 <a:solidFill>
-                  <a:srgbClr val="006D77"/>
+                  <a:srgbClr val="007BA4"/>
                 </a:solidFill>
                 <a:latin typeface="Segoe UI"/>
               </a:rPr>
@@ -47000,7 +47000,7 @@
             <a:avLst/>
           </a:prstGeom>
           <a:solidFill>
-            <a:srgbClr val="006D77"/>
+            <a:srgbClr val="007BA4"/>
           </a:solidFill>
           <a:ln>
             <a:noFill/>
@@ -47062,7 +47062,7 @@
             <a:r>
               <a:rPr sz="3000" b="1" i="0">
                 <a:solidFill>
-                  <a:srgbClr val="006D77"/>
+                  <a:srgbClr val="007BA4"/>
                 </a:solidFill>
                 <a:latin typeface="Segoe UI"/>
               </a:rPr>
@@ -47155,7 +47155,7 @@
                   </a:txBody>
                   <a:tcPr anchor="ctr" marL="91440">
                     <a:solidFill>
-                      <a:srgbClr val="006D77"/>
+                      <a:srgbClr val="007BA4"/>
                     </a:solidFill>
                   </a:tcPr>
                 </a:tc>
@@ -47177,7 +47177,7 @@
                   </a:txBody>
                   <a:tcPr anchor="ctr" marL="91440">
                     <a:solidFill>
-                      <a:srgbClr val="006D77"/>
+                      <a:srgbClr val="007BA4"/>
                     </a:solidFill>
                   </a:tcPr>
                 </a:tc>
@@ -47199,7 +47199,7 @@
                   </a:txBody>
                   <a:tcPr anchor="ctr" marL="91440">
                     <a:solidFill>
-                      <a:srgbClr val="006D77"/>
+                      <a:srgbClr val="007BA4"/>
                     </a:solidFill>
                   </a:tcPr>
                 </a:tc>

</xml_diff>